<commit_message>
Correct the onboarding layer count and the trial cap
The onboarding line checks eight layers (build / operator / layer / forward /
cache / distributed / service / quality), not six, and max_trials=6 caps total
experiments rather than candidates. Also list .hpp among the patchable
suffixes.
</commit_message>
<xml_diff>
--- a/slides/m100_model_agent.pptx
+++ b/slides/m100_model_agent.pptx
@@ -659,7 +659,7 @@
                 <a:ea typeface="Microsoft YaHei"/>
                 <a:cs typeface="Microsoft YaHei"/>
               </a:rPr>
-              <a:t>【02 / 08 · 约 50 秒（0:50）】</a:t>
+              <a:t>【02 / 08 · 约 55 秒（0:55）】</a:t>
             </a:r>
           </a:p>
           <a:p>
@@ -713,7 +713,7 @@
                 <a:ea typeface="Microsoft YaHei"/>
                 <a:cs typeface="Microsoft YaHei"/>
               </a:rPr>
-              <a:t>接入线那六层，具体是构建、算子、层、前向、缓存、服务，每一层都用冻结的 CPU 参考逐元素比对。</a:t>
+              <a:t>接入线那八层，依次是构建、算子、层、前向、缓存、分布式、服务、质量，每层都用冻结的独立 CPU 参考按 atol / rtol 逐元素裁决。</a:t>
             </a:r>
           </a:p>
           <a:p>
@@ -6132,7 +6132,7 @@
                 <a:ea typeface="Microsoft YaHei"/>
                 <a:cs typeface="Microsoft YaHei"/>
               </a:rPr>
-              <a:t>构建到服务共六层，逐层独立验收</a:t>
+              <a:t>构建到质量共八层，逐层独立验收</a:t>
             </a:r>
           </a:p>
         </p:txBody>
@@ -7490,7 +7490,7 @@
                 <a:ea typeface="Microsoft YaHei"/>
                 <a:cs typeface="Microsoft YaHei"/>
               </a:rPr>
-              <a:t>预算 36000s，最终复验预留 600s；最多 6 个候选，连续 3 个无收益即停</a:t>
+              <a:t>预算 36000s，最终复验预留 600s；实验累计上限 6 个，连续 3 个无收益即停</a:t>
             </a:r>
           </a:p>
         </p:txBody>
@@ -8580,7 +8580,7 @@
                 <a:ea typeface="Microsoft YaHei"/>
                 <a:cs typeface="Microsoft YaHei"/>
               </a:rPr>
-              <a:t>最多 6 个候选</a:t>
+              <a:t>实验累计上限 6 个</a:t>
             </a:r>
           </a:p>
         </p:txBody>
@@ -9941,7 +9941,7 @@
                 <a:ea typeface="Microsoft YaHei"/>
                 <a:cs typeface="Microsoft YaHei"/>
               </a:rPr>
-              <a:t>补丁限定 sglang/ 下的 .py / .cpp / .cu / .h / .xpu，并生成完整 changes.patch</a:t>
+              <a:t>补丁限定 sglang/ 下的 .py / .cpp / .cu / .h / .hpp / .xpu，并生成完整 changes.patch</a:t>
             </a:r>
           </a:p>
         </p:txBody>

</xml_diff>

<commit_message>
Put the human back into the model-agent flow page
Page 1 now reads as 人 -> Agent -> 人 instead of a bare pipeline:
the human freezes the contract (model, workload, thresholds, budget),
the agent runs A/B/C/D unattended, and the conclusions come back to a
human who either exports launch.sh or takes over. An outer arrow closes
the loop so verified findings become reusable rules, and a strip on top
places the run inside onboard -> run/resume -> optimize.
</commit_message>
<xml_diff>
--- a/slides/m100_model_agent.pptx
+++ b/slides/m100_model_agent.pptx
@@ -516,7 +516,7 @@
                 <a:ea typeface="Microsoft YaHei"/>
                 <a:cs typeface="Microsoft YaHei"/>
               </a:rPr>
-              <a:t>【Agent 框架 · 约 125 秒（2:05）】</a:t>
+              <a:t>【Agent 框架 · 约 155 秒（2:35）】</a:t>
             </a:r>
           </a:p>
           <a:p>
@@ -552,7 +552,7 @@
                 <a:ea typeface="Microsoft YaHei"/>
                 <a:cs typeface="Microsoft YaHei"/>
               </a:rPr>
-              <a:t>它的哲学是四步：冻结一切可变量，改只在隔离副本里改，判定交给独立的确定性门禁，全程留证据、随时可回退。一句话，它不信 LLM 的自述，一切以真机实测为准。</a:t>
+              <a:t>最上面一行是从适配到优化的三段。接入线解决新架构能不能接进来，按八层逐层验收；调优线做实测性能调优，也就是今天重点讲的这条；优化线是 trace 驱动的持续迭代。接入验收通过后，onboard --optimize 会自动交接到优化，不用人再起一次。</a:t>
             </a:r>
           </a:p>
           <a:p>
@@ -570,7 +570,7 @@
                 <a:ea typeface="Microsoft YaHei"/>
                 <a:cs typeface="Microsoft YaHei"/>
               </a:rPr>
-              <a:t>灰色这行是背景：一共三条命令线，结构同构、共用一套底座，今天只讲最成熟的调优线。</a:t>
+              <a:t>中间这张图是人和 Agent 的分工，一句话概括：人只在两头。</a:t>
             </a:r>
           </a:p>
           <a:p>
@@ -588,7 +588,7 @@
                 <a:ea typeface="Microsoft YaHei"/>
                 <a:cs typeface="Microsoft YaHei"/>
               </a:rPr>
-              <a:t>正式跑之前先自检：拿锁、校验备份和题集、每张图片对 sha256，残留的实验标记中断并清理进程。冻结物被改过就拒绝继续。</a:t>
+              <a:t>开头人定契约——模型、负载、并发、四个阈值、预算，还有已知失败对应的修复候选，全部冻结成 task.json。注意这是单向的：契约冻结之后再被改，Agent 直接拒绝继续，不会带着不确定性往下跑。</a:t>
             </a:r>
           </a:p>
           <a:p>
@@ -606,7 +606,7 @@
                 <a:ea typeface="Microsoft YaHei"/>
                 <a:cs typeface="Microsoft YaHei"/>
               </a:rPr>
-              <a:t>然后是四个阶段。A 建立工作基线，跑一次全量评测，启动失败就让规划器按日志证据提修复，每次都从原始备份重开，全失败就不往下走。B 是可选的 profiling，只用来定位、不参与收益计算。</a:t>
+              <a:t>中间这一段无人值守。A 建立工作基线，全量评测，启动失败就按日志证据提修复，最多六次；B 是可选的 profiling，只用来定位、不参与收益计算；C 是候选迭代，每个候选打补丁、连过三道门、记录收益，最多六轮——右边这个回环就是它；D 最终复验，重测基线，再对每个候选做全量复验，相对两个基线都提升才计入。</a:t>
             </a:r>
           </a:p>
           <a:p>
@@ -624,7 +624,7 @@
                 <a:ea typeface="Microsoft YaHei"/>
                 <a:cs typeface="Microsoft YaHei"/>
               </a:rPr>
-              <a:t>C 是候选迭代，预算不够或者连续三个候选没收益就停；这里有一条纪律——提实验前必须核对过真实源码并带上证据，虚构的补丁在规划阶段就被打回。</a:t>
+              <a:t>结尾交回给人：读 report 和 best，验证通过就 export 出一份独立的 launch.sh，引用的是 run 里的隔离副本，不写回共享环境；失败或者没有收益，人工接手。出了问题能回到任意一轮。</a:t>
             </a:r>
           </a:p>
           <a:p>
@@ -642,7 +642,7 @@
                 <a:ea typeface="Microsoft YaHei"/>
                 <a:cs typeface="Microsoft YaHei"/>
               </a:rPr>
-              <a:t>D 最关键：先重测一次基线，再对每个候选做全量复验，相对初始基线和重测基线都提升才计入。所以结论只有两种，要么 verified_gain 交付，要么保留基线、报告不宣称加速。</a:t>
+              <a:t>最下面这条回环是外循环，也是这套东西真正的价值所在：验证过的结论沉淀成诊断规则和候选，下一个模型直接复用。所以人工判断是逐个模型往下降的——这正好回答前面那页的命题。</a:t>
             </a:r>
           </a:p>
           <a:p>
@@ -4007,7 +4007,7 @@
                 <a:ea typeface="Microsoft YaHei"/>
                 <a:cs typeface="Microsoft YaHei"/>
               </a:rPr>
-              <a:t>AGENT 框架 · M100-MODEL-AGENT</a:t>
+              <a:t>AGENT 框架 · 人与 AGENT 的分工</a:t>
             </a:r>
           </a:p>
         </p:txBody>
@@ -4054,7 +4054,7 @@
                 <a:ea typeface="Microsoft YaHei"/>
                 <a:cs typeface="Microsoft YaHei"/>
               </a:rPr>
-              <a:t>一次 run 的四个阶段：冻结基线 → 候选迭代 → 最终复验</a:t>
+              <a:t>人定目标与口径，Agent 自动闭环，结论回到人手里</a:t>
             </a:r>
           </a:p>
         </p:txBody>
@@ -4101,68 +4101,21 @@
                 <a:ea typeface="Microsoft YaHei"/>
                 <a:cs typeface="Microsoft YaHei"/>
               </a:rPr>
-              <a:t>冻结一切可变量 · 在隔离副本里改 · 独立门禁裁决 · 留证据可回退——这四步贯穿所有代码</a:t>
-            </a:r>
-          </a:p>
-        </p:txBody>
-      </p:sp>
-      <p:sp>
-        <p:nvSpPr>
-          <p:cNvPr id="5" name="TextBox 4"/>
-          <p:cNvSpPr txBox="1"/>
-          <p:nvPr/>
-        </p:nvSpPr>
-        <p:spPr>
-          <a:xfrm>
-            <a:off x="548640" y="1664208"/>
-            <a:ext cx="11094415" cy="274320"/>
-          </a:xfrm>
-          <a:prstGeom prst="rect">
-            <a:avLst/>
-          </a:prstGeom>
-          <a:noFill/>
-        </p:spPr>
-        <p:txBody>
-          <a:bodyPr wrap="square" anchor="ctr" lIns="0" tIns="0" rIns="0" bIns="0">
-            <a:noAutofit/>
-          </a:bodyPr>
-          <a:lstStyle/>
-          <a:p>
-            <a:pPr algn="l" latinLnBrk="0">
-              <a:lnSpc>
-                <a:spcPct val="100000"/>
-              </a:lnSpc>
-              <a:spcBef>
-                <a:spcPts val="0"/>
-              </a:spcBef>
-              <a:spcAft>
-                <a:spcPts val="0"/>
-              </a:spcAft>
-            </a:pPr>
-            <a:r>
-              <a:rPr sz="1050" b="0">
-                <a:solidFill>
-                  <a:srgbClr val="66727F"/>
-                </a:solidFill>
-                <a:latin typeface="Microsoft YaHei"/>
-                <a:ea typeface="Microsoft YaHei"/>
-                <a:cs typeface="Microsoft YaHei"/>
-              </a:rPr>
-              <a:t>三条命令线结构同构、共用一套底座：调优线 run / resume（本页）　接入线 onboard-*　优化线 optimize-*</a:t>
-            </a:r>
-          </a:p>
-        </p:txBody>
-      </p:sp>
-      <p:sp>
-        <p:nvSpPr>
-          <p:cNvPr id="6" name="Rectangle 5"/>
+              <a:t>人只在两头：开头定契约与口径，结尾读结论定交付；中间的候选迭代与三道门全自动</a:t>
+            </a:r>
+          </a:p>
+        </p:txBody>
+      </p:sp>
+      <p:sp>
+        <p:nvSpPr>
+          <p:cNvPr id="5" name="Rectangle 4"/>
           <p:cNvSpPr/>
           <p:nvPr/>
         </p:nvSpPr>
         <p:spPr>
           <a:xfrm>
-            <a:off x="548640" y="2011680"/>
-            <a:ext cx="11094415" cy="420624"/>
+            <a:off x="548640" y="1682496"/>
+            <a:ext cx="3515258" cy="457200"/>
           </a:xfrm>
           <a:prstGeom prst="rect">
             <a:avLst/>
@@ -4184,14 +4137,14 @@
       </p:sp>
       <p:sp>
         <p:nvSpPr>
-          <p:cNvPr id="7" name="TextBox 6"/>
+          <p:cNvPr id="6" name="TextBox 5"/>
           <p:cNvSpPr txBox="1"/>
           <p:nvPr/>
         </p:nvSpPr>
         <p:spPr>
           <a:xfrm>
-            <a:off x="786384" y="2011680"/>
-            <a:ext cx="10618927" cy="420624"/>
+            <a:off x="749808" y="1682496"/>
+            <a:ext cx="3112922" cy="457200"/>
           </a:xfrm>
           <a:prstGeom prst="rect">
             <a:avLst/>
@@ -4216,7 +4169,7 @@
               </a:spcAft>
             </a:pPr>
             <a:r>
-              <a:rPr sz="1100" b="1">
+              <a:rPr sz="1150" b="1">
                 <a:solidFill>
                   <a:srgbClr val="16202A"/>
                 </a:solidFill>
@@ -4224,10 +4177,21 @@
                 <a:ea typeface="Microsoft YaHei"/>
                 <a:cs typeface="Microsoft YaHei"/>
               </a:rPr>
-              <a:t>执行前</a:t>
-            </a:r>
-            <a:r>
-              <a:rPr sz="1100" b="0">
+              <a:t>接入线</a:t>
+            </a:r>
+            <a:r>
+              <a:rPr sz="950" b="0">
+                <a:solidFill>
+                  <a:srgbClr val="66727F"/>
+                </a:solidFill>
+                <a:latin typeface="Consolas"/>
+                <a:ea typeface="Microsoft YaHei"/>
+                <a:cs typeface="Microsoft YaHei"/>
+              </a:rPr>
+              <a:t>　onboard-*</a:t>
+            </a:r>
+            <a:r>
+              <a:rPr sz="1000" b="0">
                 <a:solidFill>
                   <a:srgbClr val="35424F"/>
                 </a:solidFill>
@@ -4235,21 +4199,141 @@
                 <a:ea typeface="Microsoft YaHei"/>
                 <a:cs typeface="Microsoft YaHei"/>
               </a:rPr>
-              <a:t>　取 run 锁与每张卡的文件锁 · 校验备份清单 / 题集 / 每张图片 sha256 · 残留实验标记 interrupted 并清理进程</a:t>
-            </a:r>
-          </a:p>
-        </p:txBody>
-      </p:sp>
-      <p:sp>
-        <p:nvSpPr>
-          <p:cNvPr id="8" name="Rectangle 7"/>
+              <a:t>　新架构接入与分层验收</a:t>
+            </a:r>
+          </a:p>
+        </p:txBody>
+      </p:sp>
+      <p:sp>
+        <p:nvSpPr>
+          <p:cNvPr id="7" name="Rectangle 6"/>
           <p:cNvSpPr/>
           <p:nvPr/>
         </p:nvSpPr>
         <p:spPr>
           <a:xfrm>
-            <a:off x="548640" y="2615184"/>
-            <a:ext cx="2595295" cy="2139696"/>
+            <a:off x="4338218" y="1682496"/>
+            <a:ext cx="3515258" cy="457200"/>
+          </a:xfrm>
+          <a:prstGeom prst="rect">
+            <a:avLst/>
+          </a:prstGeom>
+          <a:solidFill>
+            <a:srgbClr val="F8EADF"/>
+          </a:solidFill>
+          <a:ln>
+            <a:noFill/>
+          </a:ln>
+        </p:spPr>
+        <p:txBody>
+          <a:bodyPr rtlCol="0" anchor="ctr"/>
+          <a:lstStyle/>
+          <a:p>
+            <a:pPr algn="ctr"/>
+          </a:p>
+        </p:txBody>
+      </p:sp>
+      <p:sp>
+        <p:nvSpPr>
+          <p:cNvPr id="8" name="TextBox 7"/>
+          <p:cNvSpPr txBox="1"/>
+          <p:nvPr/>
+        </p:nvSpPr>
+        <p:spPr>
+          <a:xfrm>
+            <a:off x="4539386" y="1682496"/>
+            <a:ext cx="3112922" cy="457200"/>
+          </a:xfrm>
+          <a:prstGeom prst="rect">
+            <a:avLst/>
+          </a:prstGeom>
+          <a:noFill/>
+        </p:spPr>
+        <p:txBody>
+          <a:bodyPr wrap="square" anchor="ctr" lIns="0" tIns="0" rIns="0" bIns="0">
+            <a:noAutofit/>
+          </a:bodyPr>
+          <a:lstStyle/>
+          <a:p>
+            <a:pPr algn="l" latinLnBrk="0">
+              <a:lnSpc>
+                <a:spcPct val="100000"/>
+              </a:lnSpc>
+              <a:spcBef>
+                <a:spcPts val="0"/>
+              </a:spcBef>
+              <a:spcAft>
+                <a:spcPts val="0"/>
+              </a:spcAft>
+            </a:pPr>
+            <a:r>
+              <a:rPr sz="1150" b="1">
+                <a:solidFill>
+                  <a:srgbClr val="16202A"/>
+                </a:solidFill>
+                <a:latin typeface="Microsoft YaHei"/>
+                <a:ea typeface="Microsoft YaHei"/>
+                <a:cs typeface="Microsoft YaHei"/>
+              </a:rPr>
+              <a:t>调优线</a:t>
+            </a:r>
+            <a:r>
+              <a:rPr sz="950" b="0">
+                <a:solidFill>
+                  <a:srgbClr val="C0612C"/>
+                </a:solidFill>
+                <a:latin typeface="Consolas"/>
+                <a:ea typeface="Microsoft YaHei"/>
+                <a:cs typeface="Microsoft YaHei"/>
+              </a:rPr>
+              <a:t>　run / resume</a:t>
+            </a:r>
+            <a:r>
+              <a:rPr sz="1000" b="0">
+                <a:solidFill>
+                  <a:srgbClr val="35424F"/>
+                </a:solidFill>
+                <a:latin typeface="Microsoft YaHei"/>
+                <a:ea typeface="Microsoft YaHei"/>
+                <a:cs typeface="Microsoft YaHei"/>
+              </a:rPr>
+              <a:t>　实测性能调优</a:t>
+            </a:r>
+          </a:p>
+        </p:txBody>
+      </p:sp>
+      <p:cxnSp>
+        <p:nvCxnSpPr>
+          <p:cNvPr id="9" name="Connector 8"/>
+          <p:cNvCxnSpPr/>
+          <p:nvPr/>
+        </p:nvCxnSpPr>
+        <p:spPr>
+          <a:xfrm>
+            <a:off x="4100474" y="1911095"/>
+            <a:ext cx="192024" cy="0"/>
+          </a:xfrm>
+          <a:prstGeom prst="line">
+            <a:avLst/>
+          </a:prstGeom>
+          <a:ln w="15875">
+            <a:solidFill>
+              <a:srgbClr val="C0612C"/>
+            </a:solidFill>
+            <a:tailEnd type="triangle" w="med" len="med"/>
+          </a:ln>
+        </p:spPr>
+      </p:cxnSp>
+      <p:sp>
+        <p:nvSpPr>
+          <p:cNvPr id="10" name="Rectangle 9"/>
+          <p:cNvSpPr/>
+          <p:nvPr/>
+        </p:nvSpPr>
+        <p:spPr>
+          <a:xfrm>
+            <a:off x="8127796" y="1682496"/>
+            <a:ext cx="3515258" cy="457200"/>
           </a:xfrm>
           <a:prstGeom prst="rect">
             <a:avLst/>
@@ -4271,16 +4355,136 @@
       </p:sp>
       <p:sp>
         <p:nvSpPr>
-          <p:cNvPr id="9" name="Oval 8"/>
+          <p:cNvPr id="11" name="TextBox 10"/>
+          <p:cNvSpPr txBox="1"/>
+          <p:nvPr/>
+        </p:nvSpPr>
+        <p:spPr>
+          <a:xfrm>
+            <a:off x="8328964" y="1682496"/>
+            <a:ext cx="3112922" cy="457200"/>
+          </a:xfrm>
+          <a:prstGeom prst="rect">
+            <a:avLst/>
+          </a:prstGeom>
+          <a:noFill/>
+        </p:spPr>
+        <p:txBody>
+          <a:bodyPr wrap="square" anchor="ctr" lIns="0" tIns="0" rIns="0" bIns="0">
+            <a:noAutofit/>
+          </a:bodyPr>
+          <a:lstStyle/>
+          <a:p>
+            <a:pPr algn="l" latinLnBrk="0">
+              <a:lnSpc>
+                <a:spcPct val="100000"/>
+              </a:lnSpc>
+              <a:spcBef>
+                <a:spcPts val="0"/>
+              </a:spcBef>
+              <a:spcAft>
+                <a:spcPts val="0"/>
+              </a:spcAft>
+            </a:pPr>
+            <a:r>
+              <a:rPr sz="1150" b="1">
+                <a:solidFill>
+                  <a:srgbClr val="16202A"/>
+                </a:solidFill>
+                <a:latin typeface="Microsoft YaHei"/>
+                <a:ea typeface="Microsoft YaHei"/>
+                <a:cs typeface="Microsoft YaHei"/>
+              </a:rPr>
+              <a:t>优化线</a:t>
+            </a:r>
+            <a:r>
+              <a:rPr sz="950" b="0">
+                <a:solidFill>
+                  <a:srgbClr val="66727F"/>
+                </a:solidFill>
+                <a:latin typeface="Consolas"/>
+                <a:ea typeface="Microsoft YaHei"/>
+                <a:cs typeface="Microsoft YaHei"/>
+              </a:rPr>
+              <a:t>　optimize-*</a:t>
+            </a:r>
+            <a:r>
+              <a:rPr sz="1000" b="0">
+                <a:solidFill>
+                  <a:srgbClr val="35424F"/>
+                </a:solidFill>
+                <a:latin typeface="Microsoft YaHei"/>
+                <a:ea typeface="Microsoft YaHei"/>
+                <a:cs typeface="Microsoft YaHei"/>
+              </a:rPr>
+              <a:t>　trace 驱动的持续迭代</a:t>
+            </a:r>
+          </a:p>
+        </p:txBody>
+      </p:sp>
+      <p:cxnSp>
+        <p:nvCxnSpPr>
+          <p:cNvPr id="12" name="Connector 11"/>
+          <p:cNvCxnSpPr/>
+          <p:nvPr/>
+        </p:nvCxnSpPr>
+        <p:spPr>
+          <a:xfrm>
+            <a:off x="7890052" y="1911095"/>
+            <a:ext cx="192024" cy="0"/>
+          </a:xfrm>
+          <a:prstGeom prst="line">
+            <a:avLst/>
+          </a:prstGeom>
+          <a:ln w="15875">
+            <a:solidFill>
+              <a:srgbClr val="C0612C"/>
+            </a:solidFill>
+            <a:tailEnd type="triangle" w="med" len="med"/>
+          </a:ln>
+        </p:spPr>
+      </p:cxnSp>
+      <p:sp>
+        <p:nvSpPr>
+          <p:cNvPr id="13" name="Rectangle 12"/>
           <p:cNvSpPr/>
           <p:nvPr/>
         </p:nvSpPr>
         <p:spPr>
           <a:xfrm>
-            <a:off x="768096" y="2761488"/>
-            <a:ext cx="310896" cy="310896"/>
-          </a:xfrm>
-          <a:prstGeom prst="ellipse">
+            <a:off x="548640" y="2304288"/>
+            <a:ext cx="2286000" cy="2926080"/>
+          </a:xfrm>
+          <a:prstGeom prst="rect">
+            <a:avLst/>
+          </a:prstGeom>
+          <a:solidFill>
+            <a:srgbClr val="F6F7F9"/>
+          </a:solidFill>
+          <a:ln>
+            <a:noFill/>
+          </a:ln>
+        </p:spPr>
+        <p:txBody>
+          <a:bodyPr rtlCol="0" anchor="ctr"/>
+          <a:lstStyle/>
+          <a:p>
+            <a:pPr algn="ctr"/>
+          </a:p>
+        </p:txBody>
+      </p:sp>
+      <p:sp>
+        <p:nvSpPr>
+          <p:cNvPr id="14" name="Rectangle 13"/>
+          <p:cNvSpPr/>
+          <p:nvPr/>
+        </p:nvSpPr>
+        <p:spPr>
+          <a:xfrm>
+            <a:off x="548640" y="2304288"/>
+            <a:ext cx="2286000" cy="45720"/>
+          </a:xfrm>
+          <a:prstGeom prst="rect">
             <a:avLst/>
           </a:prstGeom>
           <a:solidFill>
@@ -4291,46 +4495,23 @@
           </a:ln>
         </p:spPr>
         <p:txBody>
-          <a:bodyPr rtlCol="0" anchor="ctr" wrap="square" lIns="0" tIns="0" rIns="0" bIns="0">
-            <a:noAutofit/>
-          </a:bodyPr>
-          <a:lstStyle/>
-          <a:p>
-            <a:pPr algn="ctr" latinLnBrk="0">
-              <a:lnSpc>
-                <a:spcPct val="100000"/>
-              </a:lnSpc>
-              <a:spcBef>
-                <a:spcPts val="0"/>
-              </a:spcBef>
-              <a:spcAft>
-                <a:spcPts val="0"/>
-              </a:spcAft>
-            </a:pPr>
-            <a:r>
-              <a:rPr sz="1200" b="1">
-                <a:solidFill>
-                  <a:srgbClr val="FFFFFF"/>
-                </a:solidFill>
-                <a:latin typeface="Arial"/>
-                <a:ea typeface="Microsoft YaHei"/>
-                <a:cs typeface="Microsoft YaHei"/>
-              </a:rPr>
-              <a:t>A</a:t>
-            </a:r>
-          </a:p>
-        </p:txBody>
-      </p:sp>
-      <p:sp>
-        <p:nvSpPr>
-          <p:cNvPr id="10" name="TextBox 9"/>
+          <a:bodyPr rtlCol="0" anchor="ctr"/>
+          <a:lstStyle/>
+          <a:p>
+            <a:pPr algn="ctr"/>
+          </a:p>
+        </p:txBody>
+      </p:sp>
+      <p:sp>
+        <p:nvSpPr>
+          <p:cNvPr id="15" name="TextBox 14"/>
           <p:cNvSpPr txBox="1"/>
           <p:nvPr/>
         </p:nvSpPr>
         <p:spPr>
           <a:xfrm>
-            <a:off x="1152144" y="2743200"/>
-            <a:ext cx="1772335" cy="292608"/>
+            <a:off x="749808" y="2432304"/>
+            <a:ext cx="1883664" cy="310896"/>
           </a:xfrm>
           <a:prstGeom prst="rect">
             <a:avLst/>
@@ -4363,20 +4544,31 @@
                 <a:ea typeface="Microsoft YaHei"/>
                 <a:cs typeface="Microsoft YaHei"/>
               </a:rPr>
-              <a:t>建立工作基线</a:t>
-            </a:r>
-          </a:p>
-        </p:txBody>
-      </p:sp>
-      <p:sp>
-        <p:nvSpPr>
-          <p:cNvPr id="11" name="Oval 10"/>
+              <a:t>人</a:t>
+            </a:r>
+            <a:r>
+              <a:rPr sz="1150" b="0">
+                <a:solidFill>
+                  <a:srgbClr val="66727F"/>
+                </a:solidFill>
+                <a:latin typeface="Microsoft YaHei"/>
+                <a:ea typeface="Microsoft YaHei"/>
+                <a:cs typeface="Microsoft YaHei"/>
+              </a:rPr>
+              <a:t>　定目标与口径</a:t>
+            </a:r>
+          </a:p>
+        </p:txBody>
+      </p:sp>
+      <p:sp>
+        <p:nvSpPr>
+          <p:cNvPr id="16" name="Oval 15"/>
           <p:cNvSpPr/>
           <p:nvPr/>
         </p:nvSpPr>
         <p:spPr>
           <a:xfrm>
-            <a:off x="768096" y="3310128"/>
+            <a:off x="749808" y="2999232"/>
             <a:ext cx="91440" cy="91440"/>
           </a:xfrm>
           <a:prstGeom prst="ellipse">
@@ -4399,14 +4591,14 @@
       </p:sp>
       <p:sp>
         <p:nvSpPr>
-          <p:cNvPr id="12" name="TextBox 11"/>
+          <p:cNvPr id="17" name="TextBox 16"/>
           <p:cNvSpPr txBox="1"/>
           <p:nvPr/>
         </p:nvSpPr>
         <p:spPr>
           <a:xfrm>
-            <a:off x="969264" y="3182112"/>
-            <a:ext cx="1955215" cy="384048"/>
+            <a:off x="950976" y="2852928"/>
+            <a:ext cx="1682496" cy="420624"/>
           </a:xfrm>
           <a:prstGeom prst="rect">
             <a:avLst/>
@@ -4439,20 +4631,20 @@
                 <a:ea typeface="Microsoft YaHei"/>
                 <a:cs typeface="Microsoft YaHei"/>
               </a:rPr>
-              <a:t>首轮 000-baseline 全量评测</a:t>
-            </a:r>
-          </a:p>
-        </p:txBody>
-      </p:sp>
-      <p:sp>
-        <p:nvSpPr>
-          <p:cNvPr id="13" name="Oval 12"/>
+              <a:t>模型 / 负载 / 并发</a:t>
+            </a:r>
+          </a:p>
+        </p:txBody>
+      </p:sp>
+      <p:sp>
+        <p:nvSpPr>
+          <p:cNvPr id="18" name="Oval 17"/>
           <p:cNvSpPr/>
           <p:nvPr/>
         </p:nvSpPr>
         <p:spPr>
           <a:xfrm>
-            <a:off x="768096" y="3694176"/>
+            <a:off x="749808" y="3419856"/>
             <a:ext cx="91440" cy="91440"/>
           </a:xfrm>
           <a:prstGeom prst="ellipse">
@@ -4475,14 +4667,14 @@
       </p:sp>
       <p:sp>
         <p:nvSpPr>
-          <p:cNvPr id="14" name="TextBox 13"/>
+          <p:cNvPr id="19" name="TextBox 18"/>
           <p:cNvSpPr txBox="1"/>
           <p:nvPr/>
         </p:nvSpPr>
         <p:spPr>
           <a:xfrm>
-            <a:off x="969264" y="3566160"/>
-            <a:ext cx="1955215" cy="384048"/>
+            <a:off x="950976" y="3273552"/>
+            <a:ext cx="1682496" cy="420624"/>
           </a:xfrm>
           <a:prstGeom prst="rect">
             <a:avLst/>
@@ -4515,20 +4707,20 @@
                 <a:ea typeface="Microsoft YaHei"/>
                 <a:cs typeface="Microsoft YaHei"/>
               </a:rPr>
-              <a:t>启动失败按日志证据提修复</a:t>
-            </a:r>
-          </a:p>
-        </p:txBody>
-      </p:sp>
-      <p:sp>
-        <p:nvSpPr>
-          <p:cNvPr id="15" name="Oval 14"/>
+              <a:t>四个阈值与预算</a:t>
+            </a:r>
+          </a:p>
+        </p:txBody>
+      </p:sp>
+      <p:sp>
+        <p:nvSpPr>
+          <p:cNvPr id="20" name="Oval 19"/>
           <p:cNvSpPr/>
           <p:nvPr/>
         </p:nvSpPr>
         <p:spPr>
           <a:xfrm>
-            <a:off x="768096" y="4078224"/>
+            <a:off x="749808" y="3840480"/>
             <a:ext cx="91440" cy="91440"/>
           </a:xfrm>
           <a:prstGeom prst="ellipse">
@@ -4551,14 +4743,14 @@
       </p:sp>
       <p:sp>
         <p:nvSpPr>
-          <p:cNvPr id="16" name="TextBox 15"/>
+          <p:cNvPr id="21" name="TextBox 20"/>
           <p:cNvSpPr txBox="1"/>
           <p:nvPr/>
         </p:nvSpPr>
         <p:spPr>
           <a:xfrm>
-            <a:off x="969264" y="3950208"/>
-            <a:ext cx="1955215" cy="384048"/>
+            <a:off x="950976" y="3694176"/>
+            <a:ext cx="1682496" cy="420624"/>
           </a:xfrm>
           <a:prstGeom prst="rect">
             <a:avLst/>
@@ -4591,20 +4783,20 @@
                 <a:ea typeface="Microsoft YaHei"/>
                 <a:cs typeface="Microsoft YaHei"/>
               </a:rPr>
-              <a:t>每次从原始备份重开</a:t>
-            </a:r>
-          </a:p>
-        </p:txBody>
-      </p:sp>
-      <p:sp>
-        <p:nvSpPr>
-          <p:cNvPr id="17" name="Oval 16"/>
+              <a:t>已知失败的修复候选</a:t>
+            </a:r>
+          </a:p>
+        </p:txBody>
+      </p:sp>
+      <p:sp>
+        <p:nvSpPr>
+          <p:cNvPr id="22" name="Oval 21"/>
           <p:cNvSpPr/>
           <p:nvPr/>
         </p:nvSpPr>
         <p:spPr>
           <a:xfrm>
-            <a:off x="768096" y="4462272"/>
+            <a:off x="749808" y="4261104"/>
             <a:ext cx="91440" cy="91440"/>
           </a:xfrm>
           <a:prstGeom prst="ellipse">
@@ -4627,14 +4819,14 @@
       </p:sp>
       <p:sp>
         <p:nvSpPr>
-          <p:cNvPr id="18" name="TextBox 17"/>
+          <p:cNvPr id="23" name="TextBox 22"/>
           <p:cNvSpPr txBox="1"/>
           <p:nvPr/>
         </p:nvSpPr>
         <p:spPr>
           <a:xfrm>
-            <a:off x="969264" y="4334256"/>
-            <a:ext cx="1955215" cy="384048"/>
+            <a:off x="950976" y="4114800"/>
+            <a:ext cx="1682496" cy="420624"/>
           </a:xfrm>
           <a:prstGeom prst="rect">
             <a:avLst/>
@@ -4667,21 +4859,215 @@
                 <a:ea typeface="Microsoft YaHei"/>
                 <a:cs typeface="Microsoft YaHei"/>
               </a:rPr>
-              <a:t>全失败即 baseline_failed</a:t>
-            </a:r>
-          </a:p>
-        </p:txBody>
-      </p:sp>
-      <p:sp>
-        <p:nvSpPr>
-          <p:cNvPr id="19" name="Rectangle 18"/>
+              <a:t>冻结为 task.json</a:t>
+            </a:r>
+          </a:p>
+        </p:txBody>
+      </p:sp>
+      <p:sp>
+        <p:nvSpPr>
+          <p:cNvPr id="24" name="TextBox 23"/>
+          <p:cNvSpPr txBox="1"/>
+          <p:nvPr/>
+        </p:nvSpPr>
+        <p:spPr>
+          <a:xfrm>
+            <a:off x="749808" y="4754880"/>
+            <a:ext cx="1883664" cy="274320"/>
+          </a:xfrm>
+          <a:prstGeom prst="rect">
+            <a:avLst/>
+          </a:prstGeom>
+          <a:noFill/>
+        </p:spPr>
+        <p:txBody>
+          <a:bodyPr wrap="square" anchor="ctr" lIns="0" tIns="0" rIns="0" bIns="0">
+            <a:noAutofit/>
+          </a:bodyPr>
+          <a:lstStyle/>
+          <a:p>
+            <a:pPr algn="l" latinLnBrk="0">
+              <a:lnSpc>
+                <a:spcPct val="100000"/>
+              </a:lnSpc>
+              <a:spcBef>
+                <a:spcPts val="0"/>
+              </a:spcBef>
+              <a:spcAft>
+                <a:spcPts val="0"/>
+              </a:spcAft>
+            </a:pPr>
+            <a:r>
+              <a:rPr sz="1000" b="0">
+                <a:solidFill>
+                  <a:srgbClr val="66727F"/>
+                </a:solidFill>
+                <a:latin typeface="Microsoft YaHei"/>
+                <a:ea typeface="Microsoft YaHei"/>
+                <a:cs typeface="Microsoft YaHei"/>
+              </a:rPr>
+              <a:t>契约冻结后被改 → 拒绝继续</a:t>
+            </a:r>
+          </a:p>
+        </p:txBody>
+      </p:sp>
+      <p:sp>
+        <p:nvSpPr>
+          <p:cNvPr id="25" name="TextBox 24"/>
+          <p:cNvSpPr txBox="1"/>
+          <p:nvPr/>
+        </p:nvSpPr>
+        <p:spPr>
+          <a:xfrm>
+            <a:off x="548640" y="5010912"/>
+            <a:ext cx="2286000" cy="201168"/>
+          </a:xfrm>
+          <a:prstGeom prst="rect">
+            <a:avLst/>
+          </a:prstGeom>
+          <a:noFill/>
+        </p:spPr>
+        <p:txBody>
+          <a:bodyPr wrap="square" anchor="ctr" lIns="0" tIns="0" rIns="0" bIns="0">
+            <a:noAutofit/>
+          </a:bodyPr>
+          <a:lstStyle/>
+          <a:p>
+            <a:pPr algn="ctr" latinLnBrk="0">
+              <a:lnSpc>
+                <a:spcPct val="100000"/>
+              </a:lnSpc>
+              <a:spcBef>
+                <a:spcPts val="0"/>
+              </a:spcBef>
+              <a:spcAft>
+                <a:spcPts val="0"/>
+              </a:spcAft>
+            </a:pPr>
+            <a:r>
+              <a:rPr sz="950" b="0">
+                <a:solidFill>
+                  <a:srgbClr val="C0612C"/>
+                </a:solidFill>
+                <a:latin typeface="Consolas"/>
+                <a:ea typeface="Microsoft YaHei"/>
+                <a:cs typeface="Microsoft YaHei"/>
+              </a:rPr>
+              <a:t>交给 Agent</a:t>
+            </a:r>
+          </a:p>
+        </p:txBody>
+      </p:sp>
+      <p:sp>
+        <p:nvSpPr>
+          <p:cNvPr id="26" name="Rectangle 25"/>
           <p:cNvSpPr/>
           <p:nvPr/>
         </p:nvSpPr>
         <p:spPr>
           <a:xfrm>
-            <a:off x="3381679" y="2615184"/>
-            <a:ext cx="2595295" cy="2139696"/>
+            <a:off x="3017520" y="2304288"/>
+            <a:ext cx="5760720" cy="2926080"/>
+          </a:xfrm>
+          <a:prstGeom prst="rect">
+            <a:avLst/>
+          </a:prstGeom>
+          <a:solidFill>
+            <a:srgbClr val="FFFFFF"/>
+          </a:solidFill>
+          <a:ln w="9525">
+            <a:solidFill>
+              <a:srgbClr val="C0612C"/>
+            </a:solidFill>
+          </a:ln>
+        </p:spPr>
+        <p:txBody>
+          <a:bodyPr rtlCol="0" anchor="ctr"/>
+          <a:lstStyle/>
+          <a:p>
+            <a:pPr algn="ctr"/>
+          </a:p>
+        </p:txBody>
+      </p:sp>
+      <p:sp>
+        <p:nvSpPr>
+          <p:cNvPr id="27" name="TextBox 26"/>
+          <p:cNvSpPr txBox="1"/>
+          <p:nvPr/>
+        </p:nvSpPr>
+        <p:spPr>
+          <a:xfrm>
+            <a:off x="3218688" y="2432304"/>
+            <a:ext cx="5358383" cy="310896"/>
+          </a:xfrm>
+          <a:prstGeom prst="rect">
+            <a:avLst/>
+          </a:prstGeom>
+          <a:noFill/>
+        </p:spPr>
+        <p:txBody>
+          <a:bodyPr wrap="square" anchor="ctr" lIns="0" tIns="0" rIns="0" bIns="0">
+            <a:noAutofit/>
+          </a:bodyPr>
+          <a:lstStyle/>
+          <a:p>
+            <a:pPr algn="l" latinLnBrk="0">
+              <a:lnSpc>
+                <a:spcPct val="100000"/>
+              </a:lnSpc>
+              <a:spcBef>
+                <a:spcPts val="0"/>
+              </a:spcBef>
+              <a:spcAft>
+                <a:spcPts val="0"/>
+              </a:spcAft>
+            </a:pPr>
+            <a:r>
+              <a:rPr sz="1300" b="1">
+                <a:solidFill>
+                  <a:srgbClr val="16202A"/>
+                </a:solidFill>
+                <a:latin typeface="Consolas"/>
+                <a:ea typeface="Microsoft YaHei"/>
+                <a:cs typeface="Microsoft YaHei"/>
+              </a:rPr>
+              <a:t>Agent</a:t>
+            </a:r>
+            <a:r>
+              <a:rPr sz="1150" b="0">
+                <a:solidFill>
+                  <a:srgbClr val="66727F"/>
+                </a:solidFill>
+                <a:latin typeface="Microsoft YaHei"/>
+                <a:ea typeface="Microsoft YaHei"/>
+                <a:cs typeface="Microsoft YaHei"/>
+              </a:rPr>
+              <a:t>　自动闭环，无人值守</a:t>
+            </a:r>
+            <a:r>
+              <a:rPr sz="1000" b="0">
+                <a:solidFill>
+                  <a:srgbClr val="8C96A1"/>
+                </a:solidFill>
+                <a:latin typeface="Microsoft YaHei"/>
+                <a:ea typeface="Microsoft YaHei"/>
+                <a:cs typeface="Microsoft YaHei"/>
+              </a:rPr>
+              <a:t>　执行前先校验备份 / 题集 / 图片 sha256</a:t>
+            </a:r>
+          </a:p>
+        </p:txBody>
+      </p:sp>
+      <p:sp>
+        <p:nvSpPr>
+          <p:cNvPr id="28" name="Rectangle 27"/>
+          <p:cNvSpPr/>
+          <p:nvPr/>
+        </p:nvSpPr>
+        <p:spPr>
+          <a:xfrm>
+            <a:off x="3218688" y="2816352"/>
+            <a:ext cx="5358383" cy="493776"/>
           </a:xfrm>
           <a:prstGeom prst="rect">
             <a:avLst/>
@@ -4703,14 +5089,14 @@
       </p:sp>
       <p:sp>
         <p:nvSpPr>
-          <p:cNvPr id="20" name="Oval 19"/>
+          <p:cNvPr id="29" name="Oval 28"/>
           <p:cNvSpPr/>
           <p:nvPr/>
         </p:nvSpPr>
         <p:spPr>
           <a:xfrm>
-            <a:off x="3601135" y="2761488"/>
-            <a:ext cx="310896" cy="310896"/>
+            <a:off x="3328416" y="2926080"/>
+            <a:ext cx="274320" cy="274320"/>
           </a:xfrm>
           <a:prstGeom prst="ellipse">
             <a:avLst/>
@@ -4740,7 +5126,7 @@
               </a:spcAft>
             </a:pPr>
             <a:r>
-              <a:rPr sz="1200" b="1">
+              <a:rPr sz="1100" b="1">
                 <a:solidFill>
                   <a:srgbClr val="FFFFFF"/>
                 </a:solidFill>
@@ -4748,21 +5134,21 @@
                 <a:ea typeface="Microsoft YaHei"/>
                 <a:cs typeface="Microsoft YaHei"/>
               </a:rPr>
-              <a:t>B</a:t>
-            </a:r>
-          </a:p>
-        </p:txBody>
-      </p:sp>
-      <p:sp>
-        <p:nvSpPr>
-          <p:cNvPr id="21" name="TextBox 20"/>
+              <a:t>A</a:t>
+            </a:r>
+          </a:p>
+        </p:txBody>
+      </p:sp>
+      <p:sp>
+        <p:nvSpPr>
+          <p:cNvPr id="30" name="TextBox 29"/>
           <p:cNvSpPr txBox="1"/>
           <p:nvPr/>
         </p:nvSpPr>
         <p:spPr>
           <a:xfrm>
-            <a:off x="3985183" y="2743200"/>
-            <a:ext cx="1772335" cy="292608"/>
+            <a:off x="3694176" y="2816352"/>
+            <a:ext cx="1280160" cy="493776"/>
           </a:xfrm>
           <a:prstGeom prst="rect">
             <a:avLst/>
@@ -4787,7 +5173,7 @@
               </a:spcAft>
             </a:pPr>
             <a:r>
-              <a:rPr sz="1300" b="1">
+              <a:rPr sz="1200" b="1">
                 <a:solidFill>
                   <a:srgbClr val="16202A"/>
                 </a:solidFill>
@@ -4795,21 +5181,97 @@
                 <a:ea typeface="Microsoft YaHei"/>
                 <a:cs typeface="Microsoft YaHei"/>
               </a:rPr>
-              <a:t>Profiling（可选）</a:t>
-            </a:r>
-          </a:p>
-        </p:txBody>
-      </p:sp>
-      <p:sp>
-        <p:nvSpPr>
-          <p:cNvPr id="22" name="Oval 21"/>
+              <a:t>建立基线</a:t>
+            </a:r>
+          </a:p>
+        </p:txBody>
+      </p:sp>
+      <p:sp>
+        <p:nvSpPr>
+          <p:cNvPr id="31" name="TextBox 30"/>
+          <p:cNvSpPr txBox="1"/>
+          <p:nvPr/>
+        </p:nvSpPr>
+        <p:spPr>
+          <a:xfrm>
+            <a:off x="4892040" y="2816352"/>
+            <a:ext cx="3200400" cy="493776"/>
+          </a:xfrm>
+          <a:prstGeom prst="rect">
+            <a:avLst/>
+          </a:prstGeom>
+          <a:noFill/>
+        </p:spPr>
+        <p:txBody>
+          <a:bodyPr wrap="square" anchor="ctr" lIns="0" tIns="0" rIns="0" bIns="0">
+            <a:noAutofit/>
+          </a:bodyPr>
+          <a:lstStyle/>
+          <a:p>
+            <a:pPr algn="l" latinLnBrk="0">
+              <a:lnSpc>
+                <a:spcPct val="100000"/>
+              </a:lnSpc>
+              <a:spcBef>
+                <a:spcPts val="0"/>
+              </a:spcBef>
+              <a:spcAft>
+                <a:spcPts val="0"/>
+              </a:spcAft>
+            </a:pPr>
+            <a:r>
+              <a:rPr sz="1000" b="0">
+                <a:solidFill>
+                  <a:srgbClr val="35424F"/>
+                </a:solidFill>
+                <a:latin typeface="Microsoft YaHei"/>
+                <a:ea typeface="Microsoft YaHei"/>
+                <a:cs typeface="Microsoft YaHei"/>
+              </a:rPr>
+              <a:t>全量评测；启动失败按证据提修复，最多 6 次</a:t>
+            </a:r>
+          </a:p>
+        </p:txBody>
+      </p:sp>
+      <p:sp>
+        <p:nvSpPr>
+          <p:cNvPr id="32" name="Rectangle 31"/>
           <p:cNvSpPr/>
           <p:nvPr/>
         </p:nvSpPr>
         <p:spPr>
           <a:xfrm>
-            <a:off x="3601135" y="3310128"/>
-            <a:ext cx="91440" cy="91440"/>
+            <a:off x="3218688" y="3346704"/>
+            <a:ext cx="5358383" cy="493776"/>
+          </a:xfrm>
+          <a:prstGeom prst="rect">
+            <a:avLst/>
+          </a:prstGeom>
+          <a:solidFill>
+            <a:srgbClr val="F6F7F9"/>
+          </a:solidFill>
+          <a:ln>
+            <a:noFill/>
+          </a:ln>
+        </p:spPr>
+        <p:txBody>
+          <a:bodyPr rtlCol="0" anchor="ctr"/>
+          <a:lstStyle/>
+          <a:p>
+            <a:pPr algn="ctr"/>
+          </a:p>
+        </p:txBody>
+      </p:sp>
+      <p:sp>
+        <p:nvSpPr>
+          <p:cNvPr id="33" name="Oval 32"/>
+          <p:cNvSpPr/>
+          <p:nvPr/>
+        </p:nvSpPr>
+        <p:spPr>
+          <a:xfrm>
+            <a:off x="3328416" y="3456432"/>
+            <a:ext cx="274320" cy="274320"/>
           </a:xfrm>
           <a:prstGeom prst="ellipse">
             <a:avLst/>
@@ -4822,23 +5284,46 @@
           </a:ln>
         </p:spPr>
         <p:txBody>
-          <a:bodyPr rtlCol="0" anchor="ctr"/>
-          <a:lstStyle/>
-          <a:p>
-            <a:pPr algn="ctr"/>
-          </a:p>
-        </p:txBody>
-      </p:sp>
-      <p:sp>
-        <p:nvSpPr>
-          <p:cNvPr id="23" name="TextBox 22"/>
+          <a:bodyPr rtlCol="0" anchor="ctr" wrap="square" lIns="0" tIns="0" rIns="0" bIns="0">
+            <a:noAutofit/>
+          </a:bodyPr>
+          <a:lstStyle/>
+          <a:p>
+            <a:pPr algn="ctr" latinLnBrk="0">
+              <a:lnSpc>
+                <a:spcPct val="100000"/>
+              </a:lnSpc>
+              <a:spcBef>
+                <a:spcPts val="0"/>
+              </a:spcBef>
+              <a:spcAft>
+                <a:spcPts val="0"/>
+              </a:spcAft>
+            </a:pPr>
+            <a:r>
+              <a:rPr sz="1100" b="1">
+                <a:solidFill>
+                  <a:srgbClr val="FFFFFF"/>
+                </a:solidFill>
+                <a:latin typeface="Arial"/>
+                <a:ea typeface="Microsoft YaHei"/>
+                <a:cs typeface="Microsoft YaHei"/>
+              </a:rPr>
+              <a:t>B</a:t>
+            </a:r>
+          </a:p>
+        </p:txBody>
+      </p:sp>
+      <p:sp>
+        <p:nvSpPr>
+          <p:cNvPr id="34" name="TextBox 33"/>
           <p:cNvSpPr txBox="1"/>
           <p:nvPr/>
         </p:nvSpPr>
         <p:spPr>
           <a:xfrm>
-            <a:off x="3802303" y="3182112"/>
-            <a:ext cx="1955215" cy="384048"/>
+            <a:off x="3694176" y="3346704"/>
+            <a:ext cx="1280160" cy="493776"/>
           </a:xfrm>
           <a:prstGeom prst="rect">
             <a:avLst/>
@@ -4863,7 +5348,54 @@
               </a:spcAft>
             </a:pPr>
             <a:r>
-              <a:rPr sz="1050" b="0">
+              <a:rPr sz="1200" b="1">
+                <a:solidFill>
+                  <a:srgbClr val="16202A"/>
+                </a:solidFill>
+                <a:latin typeface="Microsoft YaHei"/>
+                <a:ea typeface="Microsoft YaHei"/>
+                <a:cs typeface="Microsoft YaHei"/>
+              </a:rPr>
+              <a:t>Profiling</a:t>
+            </a:r>
+          </a:p>
+        </p:txBody>
+      </p:sp>
+      <p:sp>
+        <p:nvSpPr>
+          <p:cNvPr id="35" name="TextBox 34"/>
+          <p:cNvSpPr txBox="1"/>
+          <p:nvPr/>
+        </p:nvSpPr>
+        <p:spPr>
+          <a:xfrm>
+            <a:off x="4892040" y="3346704"/>
+            <a:ext cx="3200400" cy="493776"/>
+          </a:xfrm>
+          <a:prstGeom prst="rect">
+            <a:avLst/>
+          </a:prstGeom>
+          <a:noFill/>
+        </p:spPr>
+        <p:txBody>
+          <a:bodyPr wrap="square" anchor="ctr" lIns="0" tIns="0" rIns="0" bIns="0">
+            <a:noAutofit/>
+          </a:bodyPr>
+          <a:lstStyle/>
+          <a:p>
+            <a:pPr algn="l" latinLnBrk="0">
+              <a:lnSpc>
+                <a:spcPct val="100000"/>
+              </a:lnSpc>
+              <a:spcBef>
+                <a:spcPts val="0"/>
+              </a:spcBef>
+              <a:spcAft>
+                <a:spcPts val="0"/>
+              </a:spcAft>
+            </a:pPr>
+            <a:r>
+              <a:rPr sz="1000" b="0">
                 <a:solidFill>
                   <a:srgbClr val="35424F"/>
                 </a:solidFill>
@@ -4871,21 +5403,50 @@
                 <a:ea typeface="Microsoft YaHei"/>
                 <a:cs typeface="Microsoft YaHei"/>
               </a:rPr>
-              <a:t>独立进程采 trace</a:t>
-            </a:r>
-          </a:p>
-        </p:txBody>
-      </p:sp>
-      <p:sp>
-        <p:nvSpPr>
-          <p:cNvPr id="24" name="Oval 23"/>
+              <a:t>独立进程采 trace，只用于定位，不参与收益计算</a:t>
+            </a:r>
+          </a:p>
+        </p:txBody>
+      </p:sp>
+      <p:sp>
+        <p:nvSpPr>
+          <p:cNvPr id="36" name="Rectangle 35"/>
           <p:cNvSpPr/>
           <p:nvPr/>
         </p:nvSpPr>
         <p:spPr>
           <a:xfrm>
-            <a:off x="3601135" y="3694176"/>
-            <a:ext cx="91440" cy="91440"/>
+            <a:off x="3218688" y="3877056"/>
+            <a:ext cx="5358383" cy="493776"/>
+          </a:xfrm>
+          <a:prstGeom prst="rect">
+            <a:avLst/>
+          </a:prstGeom>
+          <a:solidFill>
+            <a:srgbClr val="F8EADF"/>
+          </a:solidFill>
+          <a:ln>
+            <a:noFill/>
+          </a:ln>
+        </p:spPr>
+        <p:txBody>
+          <a:bodyPr rtlCol="0" anchor="ctr"/>
+          <a:lstStyle/>
+          <a:p>
+            <a:pPr algn="ctr"/>
+          </a:p>
+        </p:txBody>
+      </p:sp>
+      <p:sp>
+        <p:nvSpPr>
+          <p:cNvPr id="37" name="Oval 36"/>
+          <p:cNvSpPr/>
+          <p:nvPr/>
+        </p:nvSpPr>
+        <p:spPr>
+          <a:xfrm>
+            <a:off x="3328416" y="3986784"/>
+            <a:ext cx="274320" cy="274320"/>
           </a:xfrm>
           <a:prstGeom prst="ellipse">
             <a:avLst/>
@@ -4898,23 +5459,46 @@
           </a:ln>
         </p:spPr>
         <p:txBody>
-          <a:bodyPr rtlCol="0" anchor="ctr"/>
-          <a:lstStyle/>
-          <a:p>
-            <a:pPr algn="ctr"/>
-          </a:p>
-        </p:txBody>
-      </p:sp>
-      <p:sp>
-        <p:nvSpPr>
-          <p:cNvPr id="25" name="TextBox 24"/>
+          <a:bodyPr rtlCol="0" anchor="ctr" wrap="square" lIns="0" tIns="0" rIns="0" bIns="0">
+            <a:noAutofit/>
+          </a:bodyPr>
+          <a:lstStyle/>
+          <a:p>
+            <a:pPr algn="ctr" latinLnBrk="0">
+              <a:lnSpc>
+                <a:spcPct val="100000"/>
+              </a:lnSpc>
+              <a:spcBef>
+                <a:spcPts val="0"/>
+              </a:spcBef>
+              <a:spcAft>
+                <a:spcPts val="0"/>
+              </a:spcAft>
+            </a:pPr>
+            <a:r>
+              <a:rPr sz="1100" b="1">
+                <a:solidFill>
+                  <a:srgbClr val="FFFFFF"/>
+                </a:solidFill>
+                <a:latin typeface="Arial"/>
+                <a:ea typeface="Microsoft YaHei"/>
+                <a:cs typeface="Microsoft YaHei"/>
+              </a:rPr>
+              <a:t>C</a:t>
+            </a:r>
+          </a:p>
+        </p:txBody>
+      </p:sp>
+      <p:sp>
+        <p:nvSpPr>
+          <p:cNvPr id="38" name="TextBox 37"/>
           <p:cNvSpPr txBox="1"/>
           <p:nvPr/>
         </p:nvSpPr>
         <p:spPr>
           <a:xfrm>
-            <a:off x="3802303" y="3566160"/>
-            <a:ext cx="1955215" cy="384048"/>
+            <a:off x="3694176" y="3877056"/>
+            <a:ext cx="1280160" cy="493776"/>
           </a:xfrm>
           <a:prstGeom prst="rect">
             <a:avLst/>
@@ -4939,7 +5523,54 @@
               </a:spcAft>
             </a:pPr>
             <a:r>
-              <a:rPr sz="1050" b="0">
+              <a:rPr sz="1200" b="1">
+                <a:solidFill>
+                  <a:srgbClr val="16202A"/>
+                </a:solidFill>
+                <a:latin typeface="Microsoft YaHei"/>
+                <a:ea typeface="Microsoft YaHei"/>
+                <a:cs typeface="Microsoft YaHei"/>
+              </a:rPr>
+              <a:t>候选迭代</a:t>
+            </a:r>
+          </a:p>
+        </p:txBody>
+      </p:sp>
+      <p:sp>
+        <p:nvSpPr>
+          <p:cNvPr id="39" name="TextBox 38"/>
+          <p:cNvSpPr txBox="1"/>
+          <p:nvPr/>
+        </p:nvSpPr>
+        <p:spPr>
+          <a:xfrm>
+            <a:off x="4892040" y="3877056"/>
+            <a:ext cx="3200400" cy="493776"/>
+          </a:xfrm>
+          <a:prstGeom prst="rect">
+            <a:avLst/>
+          </a:prstGeom>
+          <a:noFill/>
+        </p:spPr>
+        <p:txBody>
+          <a:bodyPr wrap="square" anchor="ctr" lIns="0" tIns="0" rIns="0" bIns="0">
+            <a:noAutofit/>
+          </a:bodyPr>
+          <a:lstStyle/>
+          <a:p>
+            <a:pPr algn="l" latinLnBrk="0">
+              <a:lnSpc>
+                <a:spcPct val="100000"/>
+              </a:lnSpc>
+              <a:spcBef>
+                <a:spcPts val="0"/>
+              </a:spcBef>
+              <a:spcAft>
+                <a:spcPts val="0"/>
+              </a:spcAft>
+            </a:pPr>
+            <a:r>
+              <a:rPr sz="1000" b="0">
                 <a:solidFill>
                   <a:srgbClr val="35424F"/>
                 </a:solidFill>
@@ -4947,21 +5578,100 @@
                 <a:ea typeface="Microsoft YaHei"/>
                 <a:cs typeface="Microsoft YaHei"/>
               </a:rPr>
-              <a:t>只用于定位瓶颈</a:t>
-            </a:r>
-          </a:p>
-        </p:txBody>
-      </p:sp>
-      <p:sp>
-        <p:nvSpPr>
-          <p:cNvPr id="26" name="Oval 25"/>
+              <a:t>每个候选打补丁 → 过三道门 → 记收益，最多 6 轮</a:t>
+            </a:r>
+          </a:p>
+        </p:txBody>
+      </p:sp>
+      <p:sp>
+        <p:nvSpPr>
+          <p:cNvPr id="40" name="Freeform 39"/>
           <p:cNvSpPr/>
           <p:nvPr/>
         </p:nvSpPr>
         <p:spPr>
           <a:xfrm>
-            <a:off x="3601135" y="4078224"/>
-            <a:ext cx="91440" cy="91440"/>
+            <a:off x="8138160" y="3968496"/>
+            <a:ext cx="237744" cy="310896"/>
+          </a:xfrm>
+          <a:custGeom>
+            <a:avLst/>
+            <a:gdLst/>
+            <a:ahLst/>
+            <a:cxnLst/>
+            <a:rect l="l" t="t" r="r" b="b"/>
+            <a:pathLst>
+              <a:path w="237744" h="310896">
+                <a:moveTo>
+                  <a:pt x="0" y="310896"/>
+                </a:moveTo>
+                <a:lnTo>
+                  <a:pt x="237744" y="310896"/>
+                </a:lnTo>
+                <a:lnTo>
+                  <a:pt x="237744" y="0"/>
+                </a:lnTo>
+                <a:lnTo>
+                  <a:pt x="0" y="0"/>
+                </a:lnTo>
+              </a:path>
+            </a:pathLst>
+          </a:custGeom>
+          <a:noFill/>
+          <a:ln w="15875">
+            <a:solidFill>
+              <a:srgbClr val="C0612C"/>
+            </a:solidFill>
+            <a:tailEnd type="triangle" w="med" len="med"/>
+          </a:ln>
+        </p:spPr>
+        <p:txBody>
+          <a:bodyPr rtlCol="0" anchor="ctr"/>
+          <a:lstStyle/>
+          <a:p>
+            <a:pPr algn="ctr"/>
+          </a:p>
+        </p:txBody>
+      </p:sp>
+      <p:sp>
+        <p:nvSpPr>
+          <p:cNvPr id="41" name="Rectangle 40"/>
+          <p:cNvSpPr/>
+          <p:nvPr/>
+        </p:nvSpPr>
+        <p:spPr>
+          <a:xfrm>
+            <a:off x="3218688" y="4407408"/>
+            <a:ext cx="5358383" cy="493776"/>
+          </a:xfrm>
+          <a:prstGeom prst="rect">
+            <a:avLst/>
+          </a:prstGeom>
+          <a:solidFill>
+            <a:srgbClr val="F6F7F9"/>
+          </a:solidFill>
+          <a:ln>
+            <a:noFill/>
+          </a:ln>
+        </p:spPr>
+        <p:txBody>
+          <a:bodyPr rtlCol="0" anchor="ctr"/>
+          <a:lstStyle/>
+          <a:p>
+            <a:pPr algn="ctr"/>
+          </a:p>
+        </p:txBody>
+      </p:sp>
+      <p:sp>
+        <p:nvSpPr>
+          <p:cNvPr id="42" name="Oval 41"/>
+          <p:cNvSpPr/>
+          <p:nvPr/>
+        </p:nvSpPr>
+        <p:spPr>
+          <a:xfrm>
+            <a:off x="3328416" y="4517136"/>
+            <a:ext cx="274320" cy="274320"/>
           </a:xfrm>
           <a:prstGeom prst="ellipse">
             <a:avLst/>
@@ -4974,23 +5684,46 @@
           </a:ln>
         </p:spPr>
         <p:txBody>
-          <a:bodyPr rtlCol="0" anchor="ctr"/>
-          <a:lstStyle/>
-          <a:p>
-            <a:pPr algn="ctr"/>
-          </a:p>
-        </p:txBody>
-      </p:sp>
-      <p:sp>
-        <p:nvSpPr>
-          <p:cNvPr id="27" name="TextBox 26"/>
+          <a:bodyPr rtlCol="0" anchor="ctr" wrap="square" lIns="0" tIns="0" rIns="0" bIns="0">
+            <a:noAutofit/>
+          </a:bodyPr>
+          <a:lstStyle/>
+          <a:p>
+            <a:pPr algn="ctr" latinLnBrk="0">
+              <a:lnSpc>
+                <a:spcPct val="100000"/>
+              </a:lnSpc>
+              <a:spcBef>
+                <a:spcPts val="0"/>
+              </a:spcBef>
+              <a:spcAft>
+                <a:spcPts val="0"/>
+              </a:spcAft>
+            </a:pPr>
+            <a:r>
+              <a:rPr sz="1100" b="1">
+                <a:solidFill>
+                  <a:srgbClr val="FFFFFF"/>
+                </a:solidFill>
+                <a:latin typeface="Arial"/>
+                <a:ea typeface="Microsoft YaHei"/>
+                <a:cs typeface="Microsoft YaHei"/>
+              </a:rPr>
+              <a:t>D</a:t>
+            </a:r>
+          </a:p>
+        </p:txBody>
+      </p:sp>
+      <p:sp>
+        <p:nvSpPr>
+          <p:cNvPr id="43" name="TextBox 42"/>
           <p:cNvSpPr txBox="1"/>
           <p:nvPr/>
         </p:nvSpPr>
         <p:spPr>
           <a:xfrm>
-            <a:off x="3802303" y="3950208"/>
-            <a:ext cx="1955215" cy="384048"/>
+            <a:off x="3694176" y="4407408"/>
+            <a:ext cx="1280160" cy="493776"/>
           </a:xfrm>
           <a:prstGeom prst="rect">
             <a:avLst/>
@@ -5015,6 +5748,292 @@
               </a:spcAft>
             </a:pPr>
             <a:r>
+              <a:rPr sz="1200" b="1">
+                <a:solidFill>
+                  <a:srgbClr val="16202A"/>
+                </a:solidFill>
+                <a:latin typeface="Microsoft YaHei"/>
+                <a:ea typeface="Microsoft YaHei"/>
+                <a:cs typeface="Microsoft YaHei"/>
+              </a:rPr>
+              <a:t>最终复验</a:t>
+            </a:r>
+          </a:p>
+        </p:txBody>
+      </p:sp>
+      <p:sp>
+        <p:nvSpPr>
+          <p:cNvPr id="44" name="TextBox 43"/>
+          <p:cNvSpPr txBox="1"/>
+          <p:nvPr/>
+        </p:nvSpPr>
+        <p:spPr>
+          <a:xfrm>
+            <a:off x="4892040" y="4407408"/>
+            <a:ext cx="3200400" cy="493776"/>
+          </a:xfrm>
+          <a:prstGeom prst="rect">
+            <a:avLst/>
+          </a:prstGeom>
+          <a:noFill/>
+        </p:spPr>
+        <p:txBody>
+          <a:bodyPr wrap="square" anchor="ctr" lIns="0" tIns="0" rIns="0" bIns="0">
+            <a:noAutofit/>
+          </a:bodyPr>
+          <a:lstStyle/>
+          <a:p>
+            <a:pPr algn="l" latinLnBrk="0">
+              <a:lnSpc>
+                <a:spcPct val="100000"/>
+              </a:lnSpc>
+              <a:spcBef>
+                <a:spcPts val="0"/>
+              </a:spcBef>
+              <a:spcAft>
+                <a:spcPts val="0"/>
+              </a:spcAft>
+            </a:pPr>
+            <a:r>
+              <a:rPr sz="1000" b="0">
+                <a:solidFill>
+                  <a:srgbClr val="35424F"/>
+                </a:solidFill>
+                <a:latin typeface="Microsoft YaHei"/>
+                <a:ea typeface="Microsoft YaHei"/>
+                <a:cs typeface="Microsoft YaHei"/>
+              </a:rPr>
+              <a:t>重测基线，每个候选全量复验；两基线都提升才计入</a:t>
+            </a:r>
+          </a:p>
+        </p:txBody>
+      </p:sp>
+      <p:sp>
+        <p:nvSpPr>
+          <p:cNvPr id="45" name="TextBox 44"/>
+          <p:cNvSpPr txBox="1"/>
+          <p:nvPr/>
+        </p:nvSpPr>
+        <p:spPr>
+          <a:xfrm>
+            <a:off x="4892040" y="4956048"/>
+            <a:ext cx="3657600" cy="237744"/>
+          </a:xfrm>
+          <a:prstGeom prst="rect">
+            <a:avLst/>
+          </a:prstGeom>
+          <a:noFill/>
+        </p:spPr>
+        <p:txBody>
+          <a:bodyPr wrap="square" anchor="ctr" lIns="0" tIns="0" rIns="0" bIns="0">
+            <a:noAutofit/>
+          </a:bodyPr>
+          <a:lstStyle/>
+          <a:p>
+            <a:pPr algn="l" latinLnBrk="0">
+              <a:lnSpc>
+                <a:spcPct val="100000"/>
+              </a:lnSpc>
+              <a:spcBef>
+                <a:spcPts val="0"/>
+              </a:spcBef>
+              <a:spcAft>
+                <a:spcPts val="0"/>
+              </a:spcAft>
+            </a:pPr>
+            <a:r>
+              <a:rPr sz="1000" b="0">
+                <a:solidFill>
+                  <a:srgbClr val="C0612C"/>
+                </a:solidFill>
+                <a:latin typeface="Microsoft YaHei"/>
+                <a:ea typeface="Microsoft YaHei"/>
+                <a:cs typeface="Microsoft YaHei"/>
+              </a:rPr>
+              <a:t>一个候选怎么被判 → 下一页</a:t>
+            </a:r>
+          </a:p>
+        </p:txBody>
+      </p:sp>
+      <p:sp>
+        <p:nvSpPr>
+          <p:cNvPr id="46" name="Rectangle 45"/>
+          <p:cNvSpPr/>
+          <p:nvPr/>
+        </p:nvSpPr>
+        <p:spPr>
+          <a:xfrm>
+            <a:off x="8961119" y="2304288"/>
+            <a:ext cx="2681935" cy="2926080"/>
+          </a:xfrm>
+          <a:prstGeom prst="rect">
+            <a:avLst/>
+          </a:prstGeom>
+          <a:solidFill>
+            <a:srgbClr val="F6F7F9"/>
+          </a:solidFill>
+          <a:ln>
+            <a:noFill/>
+          </a:ln>
+        </p:spPr>
+        <p:txBody>
+          <a:bodyPr rtlCol="0" anchor="ctr"/>
+          <a:lstStyle/>
+          <a:p>
+            <a:pPr algn="ctr"/>
+          </a:p>
+        </p:txBody>
+      </p:sp>
+      <p:sp>
+        <p:nvSpPr>
+          <p:cNvPr id="47" name="Rectangle 46"/>
+          <p:cNvSpPr/>
+          <p:nvPr/>
+        </p:nvSpPr>
+        <p:spPr>
+          <a:xfrm>
+            <a:off x="8961119" y="2304288"/>
+            <a:ext cx="2681935" cy="45720"/>
+          </a:xfrm>
+          <a:prstGeom prst="rect">
+            <a:avLst/>
+          </a:prstGeom>
+          <a:solidFill>
+            <a:srgbClr val="C0612C"/>
+          </a:solidFill>
+          <a:ln>
+            <a:noFill/>
+          </a:ln>
+        </p:spPr>
+        <p:txBody>
+          <a:bodyPr rtlCol="0" anchor="ctr"/>
+          <a:lstStyle/>
+          <a:p>
+            <a:pPr algn="ctr"/>
+          </a:p>
+        </p:txBody>
+      </p:sp>
+      <p:sp>
+        <p:nvSpPr>
+          <p:cNvPr id="48" name="TextBox 47"/>
+          <p:cNvSpPr txBox="1"/>
+          <p:nvPr/>
+        </p:nvSpPr>
+        <p:spPr>
+          <a:xfrm>
+            <a:off x="9162288" y="2432304"/>
+            <a:ext cx="2279599" cy="310896"/>
+          </a:xfrm>
+          <a:prstGeom prst="rect">
+            <a:avLst/>
+          </a:prstGeom>
+          <a:noFill/>
+        </p:spPr>
+        <p:txBody>
+          <a:bodyPr wrap="square" anchor="ctr" lIns="0" tIns="0" rIns="0" bIns="0">
+            <a:noAutofit/>
+          </a:bodyPr>
+          <a:lstStyle/>
+          <a:p>
+            <a:pPr algn="l" latinLnBrk="0">
+              <a:lnSpc>
+                <a:spcPct val="100000"/>
+              </a:lnSpc>
+              <a:spcBef>
+                <a:spcPts val="0"/>
+              </a:spcBef>
+              <a:spcAft>
+                <a:spcPts val="0"/>
+              </a:spcAft>
+            </a:pPr>
+            <a:r>
+              <a:rPr sz="1300" b="1">
+                <a:solidFill>
+                  <a:srgbClr val="16202A"/>
+                </a:solidFill>
+                <a:latin typeface="Microsoft YaHei"/>
+                <a:ea typeface="Microsoft YaHei"/>
+                <a:cs typeface="Microsoft YaHei"/>
+              </a:rPr>
+              <a:t>人</a:t>
+            </a:r>
+            <a:r>
+              <a:rPr sz="1150" b="0">
+                <a:solidFill>
+                  <a:srgbClr val="66727F"/>
+                </a:solidFill>
+                <a:latin typeface="Microsoft YaHei"/>
+                <a:ea typeface="Microsoft YaHei"/>
+                <a:cs typeface="Microsoft YaHei"/>
+              </a:rPr>
+              <a:t>　读结论、定交付</a:t>
+            </a:r>
+          </a:p>
+        </p:txBody>
+      </p:sp>
+      <p:sp>
+        <p:nvSpPr>
+          <p:cNvPr id="49" name="Oval 48"/>
+          <p:cNvSpPr/>
+          <p:nvPr/>
+        </p:nvSpPr>
+        <p:spPr>
+          <a:xfrm>
+            <a:off x="9162288" y="2999232"/>
+            <a:ext cx="91440" cy="91440"/>
+          </a:xfrm>
+          <a:prstGeom prst="ellipse">
+            <a:avLst/>
+          </a:prstGeom>
+          <a:solidFill>
+            <a:srgbClr val="C0612C"/>
+          </a:solidFill>
+          <a:ln>
+            <a:noFill/>
+          </a:ln>
+        </p:spPr>
+        <p:txBody>
+          <a:bodyPr rtlCol="0" anchor="ctr"/>
+          <a:lstStyle/>
+          <a:p>
+            <a:pPr algn="ctr"/>
+          </a:p>
+        </p:txBody>
+      </p:sp>
+      <p:sp>
+        <p:nvSpPr>
+          <p:cNvPr id="50" name="TextBox 49"/>
+          <p:cNvSpPr txBox="1"/>
+          <p:nvPr/>
+        </p:nvSpPr>
+        <p:spPr>
+          <a:xfrm>
+            <a:off x="9363456" y="2852928"/>
+            <a:ext cx="2078431" cy="420624"/>
+          </a:xfrm>
+          <a:prstGeom prst="rect">
+            <a:avLst/>
+          </a:prstGeom>
+          <a:noFill/>
+        </p:spPr>
+        <p:txBody>
+          <a:bodyPr wrap="square" anchor="ctr" lIns="0" tIns="0" rIns="0" bIns="0">
+            <a:noAutofit/>
+          </a:bodyPr>
+          <a:lstStyle/>
+          <a:p>
+            <a:pPr algn="l" latinLnBrk="0">
+              <a:lnSpc>
+                <a:spcPct val="100000"/>
+              </a:lnSpc>
+              <a:spcBef>
+                <a:spcPts val="0"/>
+              </a:spcBef>
+              <a:spcAft>
+                <a:spcPts val="0"/>
+              </a:spcAft>
+            </a:pPr>
+            <a:r>
               <a:rPr sz="1050" b="0">
                 <a:solidFill>
                   <a:srgbClr val="35424F"/>
@@ -5023,25 +6042,368 @@
                 <a:ea typeface="Microsoft YaHei"/>
                 <a:cs typeface="Microsoft YaHei"/>
               </a:rPr>
-              <a:t>不参与收益计算</a:t>
-            </a:r>
-          </a:p>
-        </p:txBody>
-      </p:sp>
-      <p:cxnSp>
-        <p:nvCxnSpPr>
-          <p:cNvPr id="28" name="Connector 27"/>
-          <p:cNvCxnSpPr/>
-          <p:nvPr/>
-        </p:nvCxnSpPr>
-        <p:spPr>
-          <a:xfrm>
-            <a:off x="3180511" y="3685032"/>
-            <a:ext cx="164592" cy="0"/>
-          </a:xfrm>
-          <a:prstGeom prst="line">
-            <a:avLst/>
-          </a:prstGeom>
+              <a:t>读 report.md 与 best.json</a:t>
+            </a:r>
+          </a:p>
+        </p:txBody>
+      </p:sp>
+      <p:sp>
+        <p:nvSpPr>
+          <p:cNvPr id="51" name="Oval 50"/>
+          <p:cNvSpPr/>
+          <p:nvPr/>
+        </p:nvSpPr>
+        <p:spPr>
+          <a:xfrm>
+            <a:off x="9162288" y="3419856"/>
+            <a:ext cx="91440" cy="91440"/>
+          </a:xfrm>
+          <a:prstGeom prst="ellipse">
+            <a:avLst/>
+          </a:prstGeom>
+          <a:solidFill>
+            <a:srgbClr val="C0612C"/>
+          </a:solidFill>
+          <a:ln>
+            <a:noFill/>
+          </a:ln>
+        </p:spPr>
+        <p:txBody>
+          <a:bodyPr rtlCol="0" anchor="ctr"/>
+          <a:lstStyle/>
+          <a:p>
+            <a:pPr algn="ctr"/>
+          </a:p>
+        </p:txBody>
+      </p:sp>
+      <p:sp>
+        <p:nvSpPr>
+          <p:cNvPr id="52" name="TextBox 51"/>
+          <p:cNvSpPr txBox="1"/>
+          <p:nvPr/>
+        </p:nvSpPr>
+        <p:spPr>
+          <a:xfrm>
+            <a:off x="9363456" y="3273552"/>
+            <a:ext cx="2078431" cy="420624"/>
+          </a:xfrm>
+          <a:prstGeom prst="rect">
+            <a:avLst/>
+          </a:prstGeom>
+          <a:noFill/>
+        </p:spPr>
+        <p:txBody>
+          <a:bodyPr wrap="square" anchor="ctr" lIns="0" tIns="0" rIns="0" bIns="0">
+            <a:noAutofit/>
+          </a:bodyPr>
+          <a:lstStyle/>
+          <a:p>
+            <a:pPr algn="l" latinLnBrk="0">
+              <a:lnSpc>
+                <a:spcPct val="100000"/>
+              </a:lnSpc>
+              <a:spcBef>
+                <a:spcPts val="0"/>
+              </a:spcBef>
+              <a:spcAft>
+                <a:spcPts val="0"/>
+              </a:spcAft>
+            </a:pPr>
+            <a:r>
+              <a:rPr sz="1050" b="0">
+                <a:solidFill>
+                  <a:srgbClr val="35424F"/>
+                </a:solidFill>
+                <a:latin typeface="Microsoft YaHei"/>
+                <a:ea typeface="Microsoft YaHei"/>
+                <a:cs typeface="Microsoft YaHei"/>
+              </a:rPr>
+              <a:t>验证通过 → export launch.sh</a:t>
+            </a:r>
+          </a:p>
+        </p:txBody>
+      </p:sp>
+      <p:sp>
+        <p:nvSpPr>
+          <p:cNvPr id="53" name="Oval 52"/>
+          <p:cNvSpPr/>
+          <p:nvPr/>
+        </p:nvSpPr>
+        <p:spPr>
+          <a:xfrm>
+            <a:off x="9162288" y="3840480"/>
+            <a:ext cx="91440" cy="91440"/>
+          </a:xfrm>
+          <a:prstGeom prst="ellipse">
+            <a:avLst/>
+          </a:prstGeom>
+          <a:solidFill>
+            <a:srgbClr val="C0612C"/>
+          </a:solidFill>
+          <a:ln>
+            <a:noFill/>
+          </a:ln>
+        </p:spPr>
+        <p:txBody>
+          <a:bodyPr rtlCol="0" anchor="ctr"/>
+          <a:lstStyle/>
+          <a:p>
+            <a:pPr algn="ctr"/>
+          </a:p>
+        </p:txBody>
+      </p:sp>
+      <p:sp>
+        <p:nvSpPr>
+          <p:cNvPr id="54" name="TextBox 53"/>
+          <p:cNvSpPr txBox="1"/>
+          <p:nvPr/>
+        </p:nvSpPr>
+        <p:spPr>
+          <a:xfrm>
+            <a:off x="9363456" y="3694176"/>
+            <a:ext cx="2078431" cy="420624"/>
+          </a:xfrm>
+          <a:prstGeom prst="rect">
+            <a:avLst/>
+          </a:prstGeom>
+          <a:noFill/>
+        </p:spPr>
+        <p:txBody>
+          <a:bodyPr wrap="square" anchor="ctr" lIns="0" tIns="0" rIns="0" bIns="0">
+            <a:noAutofit/>
+          </a:bodyPr>
+          <a:lstStyle/>
+          <a:p>
+            <a:pPr algn="l" latinLnBrk="0">
+              <a:lnSpc>
+                <a:spcPct val="100000"/>
+              </a:lnSpc>
+              <a:spcBef>
+                <a:spcPts val="0"/>
+              </a:spcBef>
+              <a:spcAft>
+                <a:spcPts val="0"/>
+              </a:spcAft>
+            </a:pPr>
+            <a:r>
+              <a:rPr sz="1050" b="0">
+                <a:solidFill>
+                  <a:srgbClr val="35424F"/>
+                </a:solidFill>
+                <a:latin typeface="Microsoft YaHei"/>
+                <a:ea typeface="Microsoft YaHei"/>
+                <a:cs typeface="Microsoft YaHei"/>
+              </a:rPr>
+              <a:t>失败或无收益 → 人工接手</a:t>
+            </a:r>
+          </a:p>
+        </p:txBody>
+      </p:sp>
+      <p:sp>
+        <p:nvSpPr>
+          <p:cNvPr id="55" name="Oval 54"/>
+          <p:cNvSpPr/>
+          <p:nvPr/>
+        </p:nvSpPr>
+        <p:spPr>
+          <a:xfrm>
+            <a:off x="9162288" y="4261104"/>
+            <a:ext cx="91440" cy="91440"/>
+          </a:xfrm>
+          <a:prstGeom prst="ellipse">
+            <a:avLst/>
+          </a:prstGeom>
+          <a:solidFill>
+            <a:srgbClr val="C0612C"/>
+          </a:solidFill>
+          <a:ln>
+            <a:noFill/>
+          </a:ln>
+        </p:spPr>
+        <p:txBody>
+          <a:bodyPr rtlCol="0" anchor="ctr"/>
+          <a:lstStyle/>
+          <a:p>
+            <a:pPr algn="ctr"/>
+          </a:p>
+        </p:txBody>
+      </p:sp>
+      <p:sp>
+        <p:nvSpPr>
+          <p:cNvPr id="56" name="TextBox 55"/>
+          <p:cNvSpPr txBox="1"/>
+          <p:nvPr/>
+        </p:nvSpPr>
+        <p:spPr>
+          <a:xfrm>
+            <a:off x="9363456" y="4114800"/>
+            <a:ext cx="2078431" cy="420624"/>
+          </a:xfrm>
+          <a:prstGeom prst="rect">
+            <a:avLst/>
+          </a:prstGeom>
+          <a:noFill/>
+        </p:spPr>
+        <p:txBody>
+          <a:bodyPr wrap="square" anchor="ctr" lIns="0" tIns="0" rIns="0" bIns="0">
+            <a:noAutofit/>
+          </a:bodyPr>
+          <a:lstStyle/>
+          <a:p>
+            <a:pPr algn="l" latinLnBrk="0">
+              <a:lnSpc>
+                <a:spcPct val="100000"/>
+              </a:lnSpc>
+              <a:spcBef>
+                <a:spcPts val="0"/>
+              </a:spcBef>
+              <a:spcAft>
+                <a:spcPts val="0"/>
+              </a:spcAft>
+            </a:pPr>
+            <a:r>
+              <a:rPr sz="1050" b="0">
+                <a:solidFill>
+                  <a:srgbClr val="35424F"/>
+                </a:solidFill>
+                <a:latin typeface="Microsoft YaHei"/>
+                <a:ea typeface="Microsoft YaHei"/>
+                <a:cs typeface="Microsoft YaHei"/>
+              </a:rPr>
+              <a:t>每一轮都可回放追溯</a:t>
+            </a:r>
+          </a:p>
+        </p:txBody>
+      </p:sp>
+      <p:sp>
+        <p:nvSpPr>
+          <p:cNvPr id="57" name="TextBox 56"/>
+          <p:cNvSpPr txBox="1"/>
+          <p:nvPr/>
+        </p:nvSpPr>
+        <p:spPr>
+          <a:xfrm>
+            <a:off x="9162288" y="4754880"/>
+            <a:ext cx="2279599" cy="274320"/>
+          </a:xfrm>
+          <a:prstGeom prst="rect">
+            <a:avLst/>
+          </a:prstGeom>
+          <a:noFill/>
+        </p:spPr>
+        <p:txBody>
+          <a:bodyPr wrap="square" anchor="ctr" lIns="0" tIns="0" rIns="0" bIns="0">
+            <a:noAutofit/>
+          </a:bodyPr>
+          <a:lstStyle/>
+          <a:p>
+            <a:pPr algn="l" latinLnBrk="0">
+              <a:lnSpc>
+                <a:spcPct val="100000"/>
+              </a:lnSpc>
+              <a:spcBef>
+                <a:spcPts val="0"/>
+              </a:spcBef>
+              <a:spcAft>
+                <a:spcPts val="0"/>
+              </a:spcAft>
+            </a:pPr>
+            <a:r>
+              <a:rPr sz="1000" b="0">
+                <a:solidFill>
+                  <a:srgbClr val="66727F"/>
+                </a:solidFill>
+                <a:latin typeface="Microsoft YaHei"/>
+                <a:ea typeface="Microsoft YaHei"/>
+                <a:cs typeface="Microsoft YaHei"/>
+              </a:rPr>
+              <a:t>导出的 launch.sh 引用 run 内副本</a:t>
+            </a:r>
+          </a:p>
+        </p:txBody>
+      </p:sp>
+      <p:sp>
+        <p:nvSpPr>
+          <p:cNvPr id="58" name="TextBox 57"/>
+          <p:cNvSpPr txBox="1"/>
+          <p:nvPr/>
+        </p:nvSpPr>
+        <p:spPr>
+          <a:xfrm>
+            <a:off x="8961119" y="5010912"/>
+            <a:ext cx="2681935" cy="201168"/>
+          </a:xfrm>
+          <a:prstGeom prst="rect">
+            <a:avLst/>
+          </a:prstGeom>
+          <a:noFill/>
+        </p:spPr>
+        <p:txBody>
+          <a:bodyPr wrap="square" anchor="ctr" lIns="0" tIns="0" rIns="0" bIns="0">
+            <a:noAutofit/>
+          </a:bodyPr>
+          <a:lstStyle/>
+          <a:p>
+            <a:pPr algn="ctr" latinLnBrk="0">
+              <a:lnSpc>
+                <a:spcPct val="100000"/>
+              </a:lnSpc>
+              <a:spcBef>
+                <a:spcPts val="0"/>
+              </a:spcBef>
+              <a:spcAft>
+                <a:spcPts val="0"/>
+              </a:spcAft>
+            </a:pPr>
+            <a:r>
+              <a:rPr sz="950" b="0">
+                <a:solidFill>
+                  <a:srgbClr val="C0612C"/>
+                </a:solidFill>
+                <a:latin typeface="Consolas"/>
+                <a:ea typeface="Microsoft YaHei"/>
+                <a:cs typeface="Microsoft YaHei"/>
+              </a:rPr>
+              <a:t>交回给人</a:t>
+            </a:r>
+          </a:p>
+        </p:txBody>
+      </p:sp>
+      <p:sp>
+        <p:nvSpPr>
+          <p:cNvPr id="59" name="Freeform 58"/>
+          <p:cNvSpPr/>
+          <p:nvPr/>
+        </p:nvSpPr>
+        <p:spPr>
+          <a:xfrm>
+            <a:off x="1691640" y="5230368"/>
+            <a:ext cx="8610447" cy="237744"/>
+          </a:xfrm>
+          <a:custGeom>
+            <a:avLst/>
+            <a:gdLst/>
+            <a:ahLst/>
+            <a:cxnLst/>
+            <a:rect l="l" t="t" r="r" b="b"/>
+            <a:pathLst>
+              <a:path w="8610447" h="237744">
+                <a:moveTo>
+                  <a:pt x="8610447" y="0"/>
+                </a:moveTo>
+                <a:lnTo>
+                  <a:pt x="8610447" y="237744"/>
+                </a:lnTo>
+                <a:lnTo>
+                  <a:pt x="0" y="237744"/>
+                </a:lnTo>
+                <a:lnTo>
+                  <a:pt x="0" y="0"/>
+                </a:lnTo>
+              </a:path>
+            </a:pathLst>
+          </a:custGeom>
+          <a:noFill/>
           <a:ln w="15875">
             <a:solidFill>
               <a:srgbClr val="C0612C"/>
@@ -5049,59 +6411,32 @@
             <a:tailEnd type="triangle" w="med" len="med"/>
           </a:ln>
         </p:spPr>
-      </p:cxnSp>
-      <p:sp>
-        <p:nvSpPr>
-          <p:cNvPr id="29" name="Rectangle 28"/>
-          <p:cNvSpPr/>
-          <p:nvPr/>
-        </p:nvSpPr>
-        <p:spPr>
-          <a:xfrm>
-            <a:off x="6214719" y="2615184"/>
-            <a:ext cx="2595295" cy="2139696"/>
+        <p:txBody>
+          <a:bodyPr rtlCol="0" anchor="ctr"/>
+          <a:lstStyle/>
+          <a:p>
+            <a:pPr algn="ctr"/>
+          </a:p>
+        </p:txBody>
+      </p:sp>
+      <p:sp>
+        <p:nvSpPr>
+          <p:cNvPr id="60" name="TextBox 59"/>
+          <p:cNvSpPr txBox="1"/>
+          <p:nvPr/>
+        </p:nvSpPr>
+        <p:spPr>
+          <a:xfrm>
+            <a:off x="548640" y="5541264"/>
+            <a:ext cx="11094415" cy="274320"/>
           </a:xfrm>
           <a:prstGeom prst="rect">
             <a:avLst/>
           </a:prstGeom>
-          <a:solidFill>
-            <a:srgbClr val="F6F7F9"/>
-          </a:solidFill>
-          <a:ln>
-            <a:noFill/>
-          </a:ln>
-        </p:spPr>
-        <p:txBody>
-          <a:bodyPr rtlCol="0" anchor="ctr"/>
-          <a:lstStyle/>
-          <a:p>
-            <a:pPr algn="ctr"/>
-          </a:p>
-        </p:txBody>
-      </p:sp>
-      <p:sp>
-        <p:nvSpPr>
-          <p:cNvPr id="30" name="Oval 29"/>
-          <p:cNvSpPr/>
-          <p:nvPr/>
-        </p:nvSpPr>
-        <p:spPr>
-          <a:xfrm>
-            <a:off x="6434175" y="2761488"/>
-            <a:ext cx="310896" cy="310896"/>
-          </a:xfrm>
-          <a:prstGeom prst="ellipse">
-            <a:avLst/>
-          </a:prstGeom>
-          <a:solidFill>
-            <a:srgbClr val="C0612C"/>
-          </a:solidFill>
-          <a:ln>
-            <a:noFill/>
-          </a:ln>
-        </p:spPr>
-        <p:txBody>
-          <a:bodyPr rtlCol="0" anchor="ctr" wrap="square" lIns="0" tIns="0" rIns="0" bIns="0">
+          <a:noFill/>
+        </p:spPr>
+        <p:txBody>
+          <a:bodyPr wrap="square" anchor="ctr" lIns="0" tIns="0" rIns="0" bIns="0">
             <a:noAutofit/>
           </a:bodyPr>
           <a:lstStyle/>
@@ -5118,29 +6453,29 @@
               </a:spcAft>
             </a:pPr>
             <a:r>
-              <a:rPr sz="1200" b="1">
-                <a:solidFill>
-                  <a:srgbClr val="FFFFFF"/>
-                </a:solidFill>
-                <a:latin typeface="Arial"/>
-                <a:ea typeface="Microsoft YaHei"/>
-                <a:cs typeface="Microsoft YaHei"/>
-              </a:rPr>
-              <a:t>C</a:t>
-            </a:r>
-          </a:p>
-        </p:txBody>
-      </p:sp>
-      <p:sp>
-        <p:nvSpPr>
-          <p:cNvPr id="31" name="TextBox 30"/>
+              <a:rPr sz="1100" b="0">
+                <a:solidFill>
+                  <a:srgbClr val="35424F"/>
+                </a:solidFill>
+                <a:latin typeface="Microsoft YaHei"/>
+                <a:ea typeface="Microsoft YaHei"/>
+                <a:cs typeface="Microsoft YaHei"/>
+              </a:rPr>
+              <a:t>验证过的结论沉淀成诊断规则与候选 —— 下一个模型直接复用，人工判断逐次减少</a:t>
+            </a:r>
+          </a:p>
+        </p:txBody>
+      </p:sp>
+      <p:sp>
+        <p:nvSpPr>
+          <p:cNvPr id="61" name="TextBox 60"/>
           <p:cNvSpPr txBox="1"/>
           <p:nvPr/>
         </p:nvSpPr>
         <p:spPr>
           <a:xfrm>
-            <a:off x="6818223" y="2743200"/>
-            <a:ext cx="1772335" cy="292608"/>
+            <a:off x="548640" y="6382512"/>
+            <a:ext cx="9722815" cy="256032"/>
           </a:xfrm>
           <a:prstGeom prst="rect">
             <a:avLst/>
@@ -5165,1059 +6500,22 @@
               </a:spcAft>
             </a:pPr>
             <a:r>
-              <a:rPr sz="1300" b="1">
-                <a:solidFill>
-                  <a:srgbClr val="16202A"/>
+              <a:rPr sz="1000" b="0">
+                <a:solidFill>
+                  <a:srgbClr val="66727F"/>
                 </a:solidFill>
                 <a:latin typeface="Microsoft YaHei"/>
                 <a:ea typeface="Microsoft YaHei"/>
                 <a:cs typeface="Microsoft YaHei"/>
               </a:rPr>
-              <a:t>候选迭代</a:t>
-            </a:r>
-          </a:p>
-        </p:txBody>
-      </p:sp>
-      <p:sp>
-        <p:nvSpPr>
-          <p:cNvPr id="32" name="Oval 31"/>
-          <p:cNvSpPr/>
-          <p:nvPr/>
-        </p:nvSpPr>
-        <p:spPr>
-          <a:xfrm>
-            <a:off x="6434175" y="3310128"/>
-            <a:ext cx="91440" cy="91440"/>
-          </a:xfrm>
-          <a:prstGeom prst="ellipse">
-            <a:avLst/>
-          </a:prstGeom>
-          <a:solidFill>
-            <a:srgbClr val="C0612C"/>
-          </a:solidFill>
-          <a:ln>
-            <a:noFill/>
-          </a:ln>
-        </p:spPr>
-        <p:txBody>
-          <a:bodyPr rtlCol="0" anchor="ctr"/>
-          <a:lstStyle/>
-          <a:p>
-            <a:pPr algn="ctr"/>
-          </a:p>
-        </p:txBody>
-      </p:sp>
-      <p:sp>
-        <p:nvSpPr>
-          <p:cNvPr id="33" name="TextBox 32"/>
-          <p:cNvSpPr txBox="1"/>
-          <p:nvPr/>
-        </p:nvSpPr>
-        <p:spPr>
-          <a:xfrm>
-            <a:off x="6635343" y="3182112"/>
-            <a:ext cx="1955215" cy="384048"/>
-          </a:xfrm>
-          <a:prstGeom prst="rect">
-            <a:avLst/>
-          </a:prstGeom>
-          <a:noFill/>
-        </p:spPr>
-        <p:txBody>
-          <a:bodyPr wrap="square" anchor="ctr" lIns="0" tIns="0" rIns="0" bIns="0">
-            <a:noAutofit/>
-          </a:bodyPr>
-          <a:lstStyle/>
-          <a:p>
-            <a:pPr algn="l" latinLnBrk="0">
-              <a:lnSpc>
-                <a:spcPct val="100000"/>
-              </a:lnSpc>
-              <a:spcBef>
-                <a:spcPts val="0"/>
-              </a:spcBef>
-              <a:spcAft>
-                <a:spcPts val="0"/>
-              </a:spcAft>
-            </a:pPr>
-            <a:r>
-              <a:rPr sz="1050" b="0">
-                <a:solidFill>
-                  <a:srgbClr val="35424F"/>
-                </a:solidFill>
-                <a:latin typeface="Microsoft YaHei"/>
-                <a:ea typeface="Microsoft YaHei"/>
-                <a:cs typeface="Microsoft YaHei"/>
-              </a:rPr>
-              <a:t>预算 &gt; 预留 + 180s 才继续</a:t>
-            </a:r>
-          </a:p>
-        </p:txBody>
-      </p:sp>
-      <p:sp>
-        <p:nvSpPr>
-          <p:cNvPr id="34" name="Oval 33"/>
-          <p:cNvSpPr/>
-          <p:nvPr/>
-        </p:nvSpPr>
-        <p:spPr>
-          <a:xfrm>
-            <a:off x="6434175" y="3694176"/>
-            <a:ext cx="91440" cy="91440"/>
-          </a:xfrm>
-          <a:prstGeom prst="ellipse">
-            <a:avLst/>
-          </a:prstGeom>
-          <a:solidFill>
-            <a:srgbClr val="C0612C"/>
-          </a:solidFill>
-          <a:ln>
-            <a:noFill/>
-          </a:ln>
-        </p:spPr>
-        <p:txBody>
-          <a:bodyPr rtlCol="0" anchor="ctr"/>
-          <a:lstStyle/>
-          <a:p>
-            <a:pPr algn="ctr"/>
-          </a:p>
-        </p:txBody>
-      </p:sp>
-      <p:sp>
-        <p:nvSpPr>
-          <p:cNvPr id="35" name="TextBox 34"/>
-          <p:cNvSpPr txBox="1"/>
-          <p:nvPr/>
-        </p:nvSpPr>
-        <p:spPr>
-          <a:xfrm>
-            <a:off x="6635343" y="3566160"/>
-            <a:ext cx="1955215" cy="384048"/>
-          </a:xfrm>
-          <a:prstGeom prst="rect">
-            <a:avLst/>
-          </a:prstGeom>
-          <a:noFill/>
-        </p:spPr>
-        <p:txBody>
-          <a:bodyPr wrap="square" anchor="ctr" lIns="0" tIns="0" rIns="0" bIns="0">
-            <a:noAutofit/>
-          </a:bodyPr>
-          <a:lstStyle/>
-          <a:p>
-            <a:pPr algn="l" latinLnBrk="0">
-              <a:lnSpc>
-                <a:spcPct val="100000"/>
-              </a:lnSpc>
-              <a:spcBef>
-                <a:spcPts val="0"/>
-              </a:spcBef>
-              <a:spcAft>
-                <a:spcPts val="0"/>
-              </a:spcAft>
-            </a:pPr>
-            <a:r>
-              <a:rPr sz="1050" b="0">
-                <a:solidFill>
-                  <a:srgbClr val="35424F"/>
-                </a:solidFill>
-                <a:latin typeface="Microsoft YaHei"/>
-                <a:ea typeface="Microsoft YaHei"/>
-                <a:cs typeface="Microsoft YaHei"/>
-              </a:rPr>
-              <a:t>实验累计上限 6 个</a:t>
-            </a:r>
-          </a:p>
-        </p:txBody>
-      </p:sp>
-      <p:sp>
-        <p:nvSpPr>
-          <p:cNvPr id="36" name="Oval 35"/>
-          <p:cNvSpPr/>
-          <p:nvPr/>
-        </p:nvSpPr>
-        <p:spPr>
-          <a:xfrm>
-            <a:off x="6434175" y="4078224"/>
-            <a:ext cx="91440" cy="91440"/>
-          </a:xfrm>
-          <a:prstGeom prst="ellipse">
-            <a:avLst/>
-          </a:prstGeom>
-          <a:solidFill>
-            <a:srgbClr val="C0612C"/>
-          </a:solidFill>
-          <a:ln>
-            <a:noFill/>
-          </a:ln>
-        </p:spPr>
-        <p:txBody>
-          <a:bodyPr rtlCol="0" anchor="ctr"/>
-          <a:lstStyle/>
-          <a:p>
-            <a:pPr algn="ctr"/>
-          </a:p>
-        </p:txBody>
-      </p:sp>
-      <p:sp>
-        <p:nvSpPr>
-          <p:cNvPr id="37" name="TextBox 36"/>
-          <p:cNvSpPr txBox="1"/>
-          <p:nvPr/>
-        </p:nvSpPr>
-        <p:spPr>
-          <a:xfrm>
-            <a:off x="6635343" y="3950208"/>
-            <a:ext cx="1955215" cy="384048"/>
-          </a:xfrm>
-          <a:prstGeom prst="rect">
-            <a:avLst/>
-          </a:prstGeom>
-          <a:noFill/>
-        </p:spPr>
-        <p:txBody>
-          <a:bodyPr wrap="square" anchor="ctr" lIns="0" tIns="0" rIns="0" bIns="0">
-            <a:noAutofit/>
-          </a:bodyPr>
-          <a:lstStyle/>
-          <a:p>
-            <a:pPr algn="l" latinLnBrk="0">
-              <a:lnSpc>
-                <a:spcPct val="100000"/>
-              </a:lnSpc>
-              <a:spcBef>
-                <a:spcPts val="0"/>
-              </a:spcBef>
-              <a:spcAft>
-                <a:spcPts val="0"/>
-              </a:spcAft>
-            </a:pPr>
-            <a:r>
-              <a:rPr sz="1050" b="0">
-                <a:solidFill>
-                  <a:srgbClr val="35424F"/>
-                </a:solidFill>
-                <a:latin typeface="Microsoft YaHei"/>
-                <a:ea typeface="Microsoft YaHei"/>
-                <a:cs typeface="Microsoft YaHei"/>
-              </a:rPr>
-              <a:t>连续 3 个无收益即停</a:t>
-            </a:r>
-          </a:p>
-        </p:txBody>
-      </p:sp>
-      <p:sp>
-        <p:nvSpPr>
-          <p:cNvPr id="38" name="Oval 37"/>
-          <p:cNvSpPr/>
-          <p:nvPr/>
-        </p:nvSpPr>
-        <p:spPr>
-          <a:xfrm>
-            <a:off x="6434175" y="4462272"/>
-            <a:ext cx="91440" cy="91440"/>
-          </a:xfrm>
-          <a:prstGeom prst="ellipse">
-            <a:avLst/>
-          </a:prstGeom>
-          <a:solidFill>
-            <a:srgbClr val="C0612C"/>
-          </a:solidFill>
-          <a:ln>
-            <a:noFill/>
-          </a:ln>
-        </p:spPr>
-        <p:txBody>
-          <a:bodyPr rtlCol="0" anchor="ctr"/>
-          <a:lstStyle/>
-          <a:p>
-            <a:pPr algn="ctr"/>
-          </a:p>
-        </p:txBody>
-      </p:sp>
-      <p:sp>
-        <p:nvSpPr>
-          <p:cNvPr id="39" name="TextBox 38"/>
-          <p:cNvSpPr txBox="1"/>
-          <p:nvPr/>
-        </p:nvSpPr>
-        <p:spPr>
-          <a:xfrm>
-            <a:off x="6635343" y="4334256"/>
-            <a:ext cx="1955215" cy="384048"/>
-          </a:xfrm>
-          <a:prstGeom prst="rect">
-            <a:avLst/>
-          </a:prstGeom>
-          <a:noFill/>
-        </p:spPr>
-        <p:txBody>
-          <a:bodyPr wrap="square" anchor="ctr" lIns="0" tIns="0" rIns="0" bIns="0">
-            <a:noAutofit/>
-          </a:bodyPr>
-          <a:lstStyle/>
-          <a:p>
-            <a:pPr algn="l" latinLnBrk="0">
-              <a:lnSpc>
-                <a:spcPct val="100000"/>
-              </a:lnSpc>
-              <a:spcBef>
-                <a:spcPts val="0"/>
-              </a:spcBef>
-              <a:spcAft>
-                <a:spcPts val="0"/>
-              </a:spcAft>
-            </a:pPr>
-            <a:r>
-              <a:rPr sz="1050" b="0">
-                <a:solidFill>
-                  <a:srgbClr val="35424F"/>
-                </a:solidFill>
-                <a:latin typeface="Microsoft YaHei"/>
-                <a:ea typeface="Microsoft YaHei"/>
-                <a:cs typeface="Microsoft YaHei"/>
-              </a:rPr>
-              <a:t>提实验前必须核对源码带证据</a:t>
-            </a:r>
-          </a:p>
-        </p:txBody>
-      </p:sp>
-      <p:cxnSp>
-        <p:nvCxnSpPr>
-          <p:cNvPr id="40" name="Connector 39"/>
-          <p:cNvCxnSpPr/>
-          <p:nvPr/>
-        </p:nvCxnSpPr>
-        <p:spPr>
-          <a:xfrm>
-            <a:off x="6013551" y="3685032"/>
-            <a:ext cx="164592" cy="0"/>
-          </a:xfrm>
-          <a:prstGeom prst="line">
-            <a:avLst/>
-          </a:prstGeom>
-          <a:ln w="15875">
-            <a:solidFill>
-              <a:srgbClr val="C0612C"/>
-            </a:solidFill>
-            <a:tailEnd type="triangle" w="med" len="med"/>
-          </a:ln>
-        </p:spPr>
-      </p:cxnSp>
-      <p:sp>
-        <p:nvSpPr>
-          <p:cNvPr id="41" name="Rectangle 40"/>
-          <p:cNvSpPr/>
-          <p:nvPr/>
-        </p:nvSpPr>
-        <p:spPr>
-          <a:xfrm>
-            <a:off x="9047759" y="2615184"/>
-            <a:ext cx="2595295" cy="2139696"/>
-          </a:xfrm>
-          <a:prstGeom prst="rect">
-            <a:avLst/>
-          </a:prstGeom>
-          <a:solidFill>
-            <a:srgbClr val="F8EADF"/>
-          </a:solidFill>
-          <a:ln>
-            <a:noFill/>
-          </a:ln>
-        </p:spPr>
-        <p:txBody>
-          <a:bodyPr rtlCol="0" anchor="ctr"/>
-          <a:lstStyle/>
-          <a:p>
-            <a:pPr algn="ctr"/>
-          </a:p>
-        </p:txBody>
-      </p:sp>
-      <p:sp>
-        <p:nvSpPr>
-          <p:cNvPr id="42" name="Oval 41"/>
-          <p:cNvSpPr/>
-          <p:nvPr/>
-        </p:nvSpPr>
-        <p:spPr>
-          <a:xfrm>
-            <a:off x="9267215" y="2761488"/>
-            <a:ext cx="310896" cy="310896"/>
-          </a:xfrm>
-          <a:prstGeom prst="ellipse">
-            <a:avLst/>
-          </a:prstGeom>
-          <a:solidFill>
-            <a:srgbClr val="C0612C"/>
-          </a:solidFill>
-          <a:ln>
-            <a:noFill/>
-          </a:ln>
-        </p:spPr>
-        <p:txBody>
-          <a:bodyPr rtlCol="0" anchor="ctr" wrap="square" lIns="0" tIns="0" rIns="0" bIns="0">
-            <a:noAutofit/>
-          </a:bodyPr>
-          <a:lstStyle/>
-          <a:p>
-            <a:pPr algn="ctr" latinLnBrk="0">
-              <a:lnSpc>
-                <a:spcPct val="100000"/>
-              </a:lnSpc>
-              <a:spcBef>
-                <a:spcPts val="0"/>
-              </a:spcBef>
-              <a:spcAft>
-                <a:spcPts val="0"/>
-              </a:spcAft>
-            </a:pPr>
-            <a:r>
-              <a:rPr sz="1200" b="1">
-                <a:solidFill>
-                  <a:srgbClr val="FFFFFF"/>
-                </a:solidFill>
-                <a:latin typeface="Arial"/>
-                <a:ea typeface="Microsoft YaHei"/>
-                <a:cs typeface="Microsoft YaHei"/>
-              </a:rPr>
-              <a:t>D</a:t>
-            </a:r>
-          </a:p>
-        </p:txBody>
-      </p:sp>
-      <p:sp>
-        <p:nvSpPr>
-          <p:cNvPr id="43" name="TextBox 42"/>
-          <p:cNvSpPr txBox="1"/>
-          <p:nvPr/>
-        </p:nvSpPr>
-        <p:spPr>
-          <a:xfrm>
-            <a:off x="9651263" y="2743200"/>
-            <a:ext cx="1772335" cy="292608"/>
-          </a:xfrm>
-          <a:prstGeom prst="rect">
-            <a:avLst/>
-          </a:prstGeom>
-          <a:noFill/>
-        </p:spPr>
-        <p:txBody>
-          <a:bodyPr wrap="square" anchor="ctr" lIns="0" tIns="0" rIns="0" bIns="0">
-            <a:noAutofit/>
-          </a:bodyPr>
-          <a:lstStyle/>
-          <a:p>
-            <a:pPr algn="l" latinLnBrk="0">
-              <a:lnSpc>
-                <a:spcPct val="100000"/>
-              </a:lnSpc>
-              <a:spcBef>
-                <a:spcPts val="0"/>
-              </a:spcBef>
-              <a:spcAft>
-                <a:spcPts val="0"/>
-              </a:spcAft>
-            </a:pPr>
-            <a:r>
-              <a:rPr sz="1300" b="1">
-                <a:solidFill>
-                  <a:srgbClr val="16202A"/>
-                </a:solidFill>
-                <a:latin typeface="Microsoft YaHei"/>
-                <a:ea typeface="Microsoft YaHei"/>
-                <a:cs typeface="Microsoft YaHei"/>
-              </a:rPr>
-              <a:t>最终复验</a:t>
-            </a:r>
-          </a:p>
-        </p:txBody>
-      </p:sp>
-      <p:sp>
-        <p:nvSpPr>
-          <p:cNvPr id="44" name="Oval 43"/>
-          <p:cNvSpPr/>
-          <p:nvPr/>
-        </p:nvSpPr>
-        <p:spPr>
-          <a:xfrm>
-            <a:off x="9267215" y="3310128"/>
-            <a:ext cx="91440" cy="91440"/>
-          </a:xfrm>
-          <a:prstGeom prst="ellipse">
-            <a:avLst/>
-          </a:prstGeom>
-          <a:solidFill>
-            <a:srgbClr val="C0612C"/>
-          </a:solidFill>
-          <a:ln>
-            <a:noFill/>
-          </a:ln>
-        </p:spPr>
-        <p:txBody>
-          <a:bodyPr rtlCol="0" anchor="ctr"/>
-          <a:lstStyle/>
-          <a:p>
-            <a:pPr algn="ctr"/>
-          </a:p>
-        </p:txBody>
-      </p:sp>
-      <p:sp>
-        <p:nvSpPr>
-          <p:cNvPr id="45" name="TextBox 44"/>
-          <p:cNvSpPr txBox="1"/>
-          <p:nvPr/>
-        </p:nvSpPr>
-        <p:spPr>
-          <a:xfrm>
-            <a:off x="9468383" y="3182112"/>
-            <a:ext cx="1955215" cy="384048"/>
-          </a:xfrm>
-          <a:prstGeom prst="rect">
-            <a:avLst/>
-          </a:prstGeom>
-          <a:noFill/>
-        </p:spPr>
-        <p:txBody>
-          <a:bodyPr wrap="square" anchor="ctr" lIns="0" tIns="0" rIns="0" bIns="0">
-            <a:noAutofit/>
-          </a:bodyPr>
-          <a:lstStyle/>
-          <a:p>
-            <a:pPr algn="l" latinLnBrk="0">
-              <a:lnSpc>
-                <a:spcPct val="100000"/>
-              </a:lnSpc>
-              <a:spcBef>
-                <a:spcPts val="0"/>
-              </a:spcBef>
-              <a:spcAft>
-                <a:spcPts val="0"/>
-              </a:spcAft>
-            </a:pPr>
-            <a:r>
-              <a:rPr sz="1050" b="0">
-                <a:solidFill>
-                  <a:srgbClr val="35424F"/>
-                </a:solidFill>
-                <a:latin typeface="Microsoft YaHei"/>
-                <a:ea typeface="Microsoft YaHei"/>
-                <a:cs typeface="Microsoft YaHei"/>
-              </a:rPr>
-              <a:t>先重测基线（只测性能）</a:t>
-            </a:r>
-          </a:p>
-        </p:txBody>
-      </p:sp>
-      <p:sp>
-        <p:nvSpPr>
-          <p:cNvPr id="46" name="Oval 45"/>
-          <p:cNvSpPr/>
-          <p:nvPr/>
-        </p:nvSpPr>
-        <p:spPr>
-          <a:xfrm>
-            <a:off x="9267215" y="3694176"/>
-            <a:ext cx="91440" cy="91440"/>
-          </a:xfrm>
-          <a:prstGeom prst="ellipse">
-            <a:avLst/>
-          </a:prstGeom>
-          <a:solidFill>
-            <a:srgbClr val="C0612C"/>
-          </a:solidFill>
-          <a:ln>
-            <a:noFill/>
-          </a:ln>
-        </p:spPr>
-        <p:txBody>
-          <a:bodyPr rtlCol="0" anchor="ctr"/>
-          <a:lstStyle/>
-          <a:p>
-            <a:pPr algn="ctr"/>
-          </a:p>
-        </p:txBody>
-      </p:sp>
-      <p:sp>
-        <p:nvSpPr>
-          <p:cNvPr id="47" name="TextBox 46"/>
-          <p:cNvSpPr txBox="1"/>
-          <p:nvPr/>
-        </p:nvSpPr>
-        <p:spPr>
-          <a:xfrm>
-            <a:off x="9468383" y="3566160"/>
-            <a:ext cx="1955215" cy="384048"/>
-          </a:xfrm>
-          <a:prstGeom prst="rect">
-            <a:avLst/>
-          </a:prstGeom>
-          <a:noFill/>
-        </p:spPr>
-        <p:txBody>
-          <a:bodyPr wrap="square" anchor="ctr" lIns="0" tIns="0" rIns="0" bIns="0">
-            <a:noAutofit/>
-          </a:bodyPr>
-          <a:lstStyle/>
-          <a:p>
-            <a:pPr algn="l" latinLnBrk="0">
-              <a:lnSpc>
-                <a:spcPct val="100000"/>
-              </a:lnSpc>
-              <a:spcBef>
-                <a:spcPts val="0"/>
-              </a:spcBef>
-              <a:spcAft>
-                <a:spcPts val="0"/>
-              </a:spcAft>
-            </a:pPr>
-            <a:r>
-              <a:rPr sz="1050" b="0">
-                <a:solidFill>
-                  <a:srgbClr val="35424F"/>
-                </a:solidFill>
-                <a:latin typeface="Microsoft YaHei"/>
-                <a:ea typeface="Microsoft YaHei"/>
-                <a:cs typeface="Microsoft YaHei"/>
-              </a:rPr>
-              <a:t>每个候选做全量复验</a:t>
-            </a:r>
-          </a:p>
-        </p:txBody>
-      </p:sp>
-      <p:sp>
-        <p:nvSpPr>
-          <p:cNvPr id="48" name="Oval 47"/>
-          <p:cNvSpPr/>
-          <p:nvPr/>
-        </p:nvSpPr>
-        <p:spPr>
-          <a:xfrm>
-            <a:off x="9267215" y="4078224"/>
-            <a:ext cx="91440" cy="91440"/>
-          </a:xfrm>
-          <a:prstGeom prst="ellipse">
-            <a:avLst/>
-          </a:prstGeom>
-          <a:solidFill>
-            <a:srgbClr val="C0612C"/>
-          </a:solidFill>
-          <a:ln>
-            <a:noFill/>
-          </a:ln>
-        </p:spPr>
-        <p:txBody>
-          <a:bodyPr rtlCol="0" anchor="ctr"/>
-          <a:lstStyle/>
-          <a:p>
-            <a:pPr algn="ctr"/>
-          </a:p>
-        </p:txBody>
-      </p:sp>
-      <p:sp>
-        <p:nvSpPr>
-          <p:cNvPr id="49" name="TextBox 48"/>
-          <p:cNvSpPr txBox="1"/>
-          <p:nvPr/>
-        </p:nvSpPr>
-        <p:spPr>
-          <a:xfrm>
-            <a:off x="9468383" y="3950208"/>
-            <a:ext cx="1955215" cy="384048"/>
-          </a:xfrm>
-          <a:prstGeom prst="rect">
-            <a:avLst/>
-          </a:prstGeom>
-          <a:noFill/>
-        </p:spPr>
-        <p:txBody>
-          <a:bodyPr wrap="square" anchor="ctr" lIns="0" tIns="0" rIns="0" bIns="0">
-            <a:noAutofit/>
-          </a:bodyPr>
-          <a:lstStyle/>
-          <a:p>
-            <a:pPr algn="l" latinLnBrk="0">
-              <a:lnSpc>
-                <a:spcPct val="100000"/>
-              </a:lnSpc>
-              <a:spcBef>
-                <a:spcPts val="0"/>
-              </a:spcBef>
-              <a:spcAft>
-                <a:spcPts val="0"/>
-              </a:spcAft>
-            </a:pPr>
-            <a:r>
-              <a:rPr sz="1050" b="0">
-                <a:solidFill>
-                  <a:srgbClr val="35424F"/>
-                </a:solidFill>
-                <a:latin typeface="Microsoft YaHei"/>
-                <a:ea typeface="Microsoft YaHei"/>
-                <a:cs typeface="Microsoft YaHei"/>
-              </a:rPr>
-              <a:t>两个基线都提升才计入</a:t>
-            </a:r>
-          </a:p>
-        </p:txBody>
-      </p:sp>
-      <p:sp>
-        <p:nvSpPr>
-          <p:cNvPr id="50" name="Oval 49"/>
-          <p:cNvSpPr/>
-          <p:nvPr/>
-        </p:nvSpPr>
-        <p:spPr>
-          <a:xfrm>
-            <a:off x="9267215" y="4462272"/>
-            <a:ext cx="91440" cy="91440"/>
-          </a:xfrm>
-          <a:prstGeom prst="ellipse">
-            <a:avLst/>
-          </a:prstGeom>
-          <a:solidFill>
-            <a:srgbClr val="C0612C"/>
-          </a:solidFill>
-          <a:ln>
-            <a:noFill/>
-          </a:ln>
-        </p:spPr>
-        <p:txBody>
-          <a:bodyPr rtlCol="0" anchor="ctr"/>
-          <a:lstStyle/>
-          <a:p>
-            <a:pPr algn="ctr"/>
-          </a:p>
-        </p:txBody>
-      </p:sp>
-      <p:sp>
-        <p:nvSpPr>
-          <p:cNvPr id="51" name="TextBox 50"/>
-          <p:cNvSpPr txBox="1"/>
-          <p:nvPr/>
-        </p:nvSpPr>
-        <p:spPr>
-          <a:xfrm>
-            <a:off x="9468383" y="4334256"/>
-            <a:ext cx="1955215" cy="384048"/>
-          </a:xfrm>
-          <a:prstGeom prst="rect">
-            <a:avLst/>
-          </a:prstGeom>
-          <a:noFill/>
-        </p:spPr>
-        <p:txBody>
-          <a:bodyPr wrap="square" anchor="ctr" lIns="0" tIns="0" rIns="0" bIns="0">
-            <a:noAutofit/>
-          </a:bodyPr>
-          <a:lstStyle/>
-          <a:p>
-            <a:pPr algn="l" latinLnBrk="0">
-              <a:lnSpc>
-                <a:spcPct val="100000"/>
-              </a:lnSpc>
-              <a:spcBef>
-                <a:spcPts val="0"/>
-              </a:spcBef>
-              <a:spcAft>
-                <a:spcPts val="0"/>
-              </a:spcAft>
-            </a:pPr>
-            <a:r>
-              <a:rPr sz="1050" b="0">
-                <a:solidFill>
-                  <a:srgbClr val="35424F"/>
-                </a:solidFill>
-                <a:latin typeface="Microsoft YaHei"/>
-                <a:ea typeface="Microsoft YaHei"/>
-                <a:cs typeface="Microsoft YaHei"/>
-              </a:rPr>
-              <a:t>否则保留基线不宣称加速</a:t>
-            </a:r>
-          </a:p>
-        </p:txBody>
-      </p:sp>
-      <p:cxnSp>
-        <p:nvCxnSpPr>
-          <p:cNvPr id="52" name="Connector 51"/>
-          <p:cNvCxnSpPr/>
-          <p:nvPr/>
-        </p:nvCxnSpPr>
-        <p:spPr>
-          <a:xfrm>
-            <a:off x="8846591" y="3685032"/>
-            <a:ext cx="164592" cy="0"/>
-          </a:xfrm>
-          <a:prstGeom prst="line">
-            <a:avLst/>
-          </a:prstGeom>
-          <a:ln w="15875">
-            <a:solidFill>
-              <a:srgbClr val="C0612C"/>
-            </a:solidFill>
-            <a:tailEnd type="triangle" w="med" len="med"/>
-          </a:ln>
-        </p:spPr>
-      </p:cxnSp>
-      <p:sp>
-        <p:nvSpPr>
-          <p:cNvPr id="53" name="TextBox 52"/>
-          <p:cNvSpPr txBox="1"/>
-          <p:nvPr/>
-        </p:nvSpPr>
-        <p:spPr>
-          <a:xfrm>
-            <a:off x="6434175" y="4791456"/>
-            <a:ext cx="2595295" cy="237744"/>
-          </a:xfrm>
-          <a:prstGeom prst="rect">
-            <a:avLst/>
-          </a:prstGeom>
-          <a:noFill/>
-        </p:spPr>
-        <p:txBody>
-          <a:bodyPr wrap="square" anchor="ctr" lIns="0" tIns="0" rIns="0" bIns="0">
-            <a:noAutofit/>
-          </a:bodyPr>
-          <a:lstStyle/>
-          <a:p>
-            <a:pPr algn="l" latinLnBrk="0">
-              <a:lnSpc>
-                <a:spcPct val="100000"/>
-              </a:lnSpc>
-              <a:spcBef>
-                <a:spcPts val="0"/>
-              </a:spcBef>
-              <a:spcAft>
-                <a:spcPts val="0"/>
-              </a:spcAft>
-            </a:pPr>
-            <a:r>
-              <a:rPr sz="1000" b="0">
-                <a:solidFill>
-                  <a:srgbClr val="C0612C"/>
-                </a:solidFill>
-                <a:latin typeface="Microsoft YaHei"/>
-                <a:ea typeface="Microsoft YaHei"/>
-                <a:cs typeface="Microsoft YaHei"/>
-              </a:rPr>
-              <a:t>每个候选怎么被判 → 下一页</a:t>
-            </a:r>
-          </a:p>
-        </p:txBody>
-      </p:sp>
-      <p:sp>
-        <p:nvSpPr>
-          <p:cNvPr id="54" name="Rectangle 53"/>
-          <p:cNvSpPr/>
-          <p:nvPr/>
-        </p:nvSpPr>
-        <p:spPr>
-          <a:xfrm>
-            <a:off x="548640" y="5120640"/>
-            <a:ext cx="11094415" cy="877824"/>
-          </a:xfrm>
-          <a:prstGeom prst="rect">
-            <a:avLst/>
-          </a:prstGeom>
-          <a:solidFill>
-            <a:srgbClr val="F8EADF"/>
-          </a:solidFill>
-          <a:ln>
-            <a:noFill/>
-          </a:ln>
-        </p:spPr>
-        <p:txBody>
-          <a:bodyPr rtlCol="0" anchor="ctr"/>
-          <a:lstStyle/>
-          <a:p>
-            <a:pPr algn="ctr"/>
-          </a:p>
-        </p:txBody>
-      </p:sp>
-      <p:sp>
-        <p:nvSpPr>
-          <p:cNvPr id="55" name="Rectangle 54"/>
-          <p:cNvSpPr/>
-          <p:nvPr/>
-        </p:nvSpPr>
-        <p:spPr>
-          <a:xfrm>
-            <a:off x="548640" y="5120640"/>
-            <a:ext cx="64008" cy="877824"/>
-          </a:xfrm>
-          <a:prstGeom prst="rect">
-            <a:avLst/>
-          </a:prstGeom>
-          <a:solidFill>
-            <a:srgbClr val="C0612C"/>
-          </a:solidFill>
-          <a:ln>
-            <a:noFill/>
-          </a:ln>
-        </p:spPr>
-        <p:txBody>
-          <a:bodyPr rtlCol="0" anchor="ctr"/>
-          <a:lstStyle/>
-          <a:p>
-            <a:pPr algn="ctr"/>
-          </a:p>
-        </p:txBody>
-      </p:sp>
-      <p:sp>
-        <p:nvSpPr>
-          <p:cNvPr id="56" name="TextBox 55"/>
-          <p:cNvSpPr txBox="1"/>
-          <p:nvPr/>
-        </p:nvSpPr>
-        <p:spPr>
-          <a:xfrm>
-            <a:off x="859536" y="5230368"/>
-            <a:ext cx="10454335" cy="365760"/>
-          </a:xfrm>
-          <a:prstGeom prst="rect">
-            <a:avLst/>
-          </a:prstGeom>
-          <a:noFill/>
-        </p:spPr>
-        <p:txBody>
-          <a:bodyPr wrap="square" anchor="ctr" lIns="0" tIns="0" rIns="0" bIns="0">
-            <a:noAutofit/>
-          </a:bodyPr>
-          <a:lstStyle/>
-          <a:p>
-            <a:pPr algn="l" latinLnBrk="0">
-              <a:lnSpc>
-                <a:spcPct val="100000"/>
-              </a:lnSpc>
-              <a:spcBef>
-                <a:spcPts val="0"/>
-              </a:spcBef>
-              <a:spcAft>
-                <a:spcPts val="0"/>
-              </a:spcAft>
-            </a:pPr>
-            <a:r>
-              <a:rPr sz="1200" b="1">
-                <a:solidFill>
-                  <a:srgbClr val="C0612C"/>
-                </a:solidFill>
-                <a:latin typeface="Consolas"/>
-                <a:ea typeface="Microsoft YaHei"/>
-                <a:cs typeface="Microsoft YaHei"/>
-              </a:rPr>
-              <a:t>结论只有两种　</a:t>
-            </a:r>
-            <a:r>
-              <a:rPr sz="1600" b="1">
-                <a:solidFill>
-                  <a:srgbClr val="16202A"/>
-                </a:solidFill>
-                <a:latin typeface="Microsoft YaHei"/>
-                <a:ea typeface="Microsoft YaHei"/>
-                <a:cs typeface="Microsoft YaHei"/>
-              </a:rPr>
-              <a:t>verified_gain 交付，或 baseline_retained 保留基线</a:t>
-            </a:r>
-          </a:p>
-        </p:txBody>
-      </p:sp>
-      <p:sp>
-        <p:nvSpPr>
-          <p:cNvPr id="57" name="TextBox 56"/>
-          <p:cNvSpPr txBox="1"/>
-          <p:nvPr/>
-        </p:nvSpPr>
-        <p:spPr>
-          <a:xfrm>
-            <a:off x="859536" y="5650992"/>
-            <a:ext cx="10454335" cy="274320"/>
-          </a:xfrm>
-          <a:prstGeom prst="rect">
-            <a:avLst/>
-          </a:prstGeom>
-          <a:noFill/>
-        </p:spPr>
-        <p:txBody>
-          <a:bodyPr wrap="square" anchor="ctr" lIns="0" tIns="0" rIns="0" bIns="0">
-            <a:noAutofit/>
-          </a:bodyPr>
-          <a:lstStyle/>
-          <a:p>
-            <a:pPr algn="l" latinLnBrk="0">
-              <a:lnSpc>
-                <a:spcPct val="100000"/>
-              </a:lnSpc>
-              <a:spcBef>
-                <a:spcPts val="0"/>
-              </a:spcBef>
-              <a:spcAft>
-                <a:spcPts val="0"/>
-              </a:spcAft>
-            </a:pPr>
-            <a:r>
-              <a:rPr sz="1150" b="0">
-                <a:solidFill>
-                  <a:srgbClr val="35424F"/>
-                </a:solidFill>
-                <a:latin typeface="Microsoft YaHei"/>
-                <a:ea typeface="Microsoft YaHei"/>
-                <a:cs typeface="Microsoft YaHei"/>
-              </a:rPr>
-              <a:t>筛选收益 ≠ 交付收益：相对初始基线与重测基线都提升才计入，否则报告不宣称加速</a:t>
-            </a:r>
-          </a:p>
-        </p:txBody>
-      </p:sp>
-      <p:sp>
-        <p:nvSpPr>
-          <p:cNvPr id="58" name="TextBox 57"/>
-          <p:cNvSpPr txBox="1"/>
-          <p:nvPr/>
-        </p:nvSpPr>
-        <p:spPr>
-          <a:xfrm>
-            <a:off x="548640" y="6382512"/>
-            <a:ext cx="9722815" cy="256032"/>
-          </a:xfrm>
-          <a:prstGeom prst="rect">
-            <a:avLst/>
-          </a:prstGeom>
-          <a:noFill/>
-        </p:spPr>
-        <p:txBody>
-          <a:bodyPr wrap="square" anchor="ctr" lIns="0" tIns="0" rIns="0" bIns="0">
-            <a:noAutofit/>
-          </a:bodyPr>
-          <a:lstStyle/>
-          <a:p>
-            <a:pPr algn="l" latinLnBrk="0">
-              <a:lnSpc>
-                <a:spcPct val="100000"/>
-              </a:lnSpc>
-              <a:spcBef>
-                <a:spcPts val="0"/>
-              </a:spcBef>
-              <a:spcAft>
-                <a:spcPts val="0"/>
-              </a:spcAft>
-            </a:pPr>
-            <a:r>
-              <a:rPr sz="1000" b="0">
-                <a:solidFill>
-                  <a:srgbClr val="66727F"/>
-                </a:solidFill>
-                <a:latin typeface="Microsoft YaHei"/>
-                <a:ea typeface="Microsoft YaHei"/>
-                <a:cs typeface="Microsoft YaHei"/>
-              </a:rPr>
-              <a:t>预算 36000s，最终复验预留 600s；底座模块（契约 / 隔离 / 门禁 / 规划 / 构建 / 设备）被三条命令线共享</a:t>
-            </a:r>
-          </a:p>
-        </p:txBody>
-      </p:sp>
-      <p:sp>
-        <p:nvSpPr>
-          <p:cNvPr id="59" name="TextBox 58"/>
+              <a:t>onboard --optimize 验收通过后自动交接到优化；预算 36000s，最终复验预留 600s</a:t>
+            </a:r>
+          </a:p>
+        </p:txBody>
+      </p:sp>
+      <p:sp>
+        <p:nvSpPr>
+          <p:cNvPr id="62" name="TextBox 61"/>
           <p:cNvSpPr txBox="1"/>
           <p:nvPr/>
         </p:nvSpPr>

</xml_diff>

<commit_message>
Raise the register of the model-agent section
The audience hears each line once and cannot re-read it, so in-house
shorthand is a comprehension tax. Spell out the three command lines as
架构接入 / 性能调优 / 持续优化, replace the clipped arrow notation with
full predicates, and name 人工 rather than 人.

The narration shrinks back to its original 4:20 despite the longer
wording: it no longer reads the slide aloud. Each paragraph now carries
what the slide cannot show -- why the gates run cheapest-first, why a
gain below the noise floor is not a gain, what candidates would game if
the anti-cheat checks were absent.
</commit_message>
<xml_diff>
--- a/slides/m100_model_agent.pptx
+++ b/slides/m100_model_agent.pptx
@@ -516,7 +516,7 @@
                 <a:ea typeface="Microsoft YaHei"/>
                 <a:cs typeface="Microsoft YaHei"/>
               </a:rPr>
-              <a:t>【Agent 框架 · 约 155 秒（2:35）】</a:t>
+              <a:t>【Agent 框架 · 约 145 秒（2:25）】</a:t>
             </a:r>
           </a:p>
           <a:p>
@@ -534,7 +534,7 @@
                 <a:ea typeface="Microsoft YaHei"/>
                 <a:cs typeface="Microsoft YaHei"/>
               </a:rPr>
-              <a:t>这套 Agent 在 M100 上做两件事：把模型适配下来，再把性能调上去。执行后端是 SGLang，第一个任务是 Qwen3-VL-8B 的 channel-FP8。</a:t>
+              <a:t>这套 Agent 在 M100 上承担两项工作：完成模型适配，并在实测环境中提升性能。执行后端是 SGLang，首个任务是 Qwen3-VL-8B 的 channel-FP8。</a:t>
             </a:r>
           </a:p>
           <a:p>
@@ -552,7 +552,7 @@
                 <a:ea typeface="Microsoft YaHei"/>
                 <a:cs typeface="Microsoft YaHei"/>
               </a:rPr>
-              <a:t>最上面一行是从适配到优化的三段。接入线解决新架构能不能接进来，按八层逐层验收；调优线做实测性能调优，也就是今天重点讲的这条；优化线是 trace 驱动的持续迭代。接入验收通过后，onboard --optimize 会自动交接到优化，不用人再起一次。</a:t>
+              <a:t>最上面一行是三个阶段：架构接入解决能否正确运行，按八个层次逐层验收；性能调优解决运行效率，是本页的重点；持续优化基于 trace 做长期迭代。接入验收通过后自动交接到优化阶段，无需人工再次发起。</a:t>
             </a:r>
           </a:p>
           <a:p>
@@ -570,7 +570,7 @@
                 <a:ea typeface="Microsoft YaHei"/>
                 <a:cs typeface="Microsoft YaHei"/>
               </a:rPr>
-              <a:t>中间这张图是人和 Agent 的分工，一句话概括：人只在两头。</a:t>
+              <a:t>下面这张图回答一个问题：人工在其中做什么。答案是只出现在首尾两端。</a:t>
             </a:r>
           </a:p>
           <a:p>
@@ -588,7 +588,7 @@
                 <a:ea typeface="Microsoft YaHei"/>
                 <a:cs typeface="Microsoft YaHei"/>
               </a:rPr>
-              <a:t>开头人定契约——模型、负载、并发、四个阈值、预算，还有已知失败对应的修复候选，全部冻结成 task.json。注意这是单向的：契约冻结之后再被改，Agent 直接拒绝继续，不会带着不确定性往下跑。</a:t>
+              <a:t>开始之前，由人工把目标和口径冻结为 task.json。关键在于单向——契约一经冻结，任何修改都会使 Agent 终止运行。所有阈值都在这一刻确定，后面不再有解释空间。</a:t>
             </a:r>
           </a:p>
           <a:p>
@@ -606,7 +606,7 @@
                 <a:ea typeface="Microsoft YaHei"/>
                 <a:cs typeface="Microsoft YaHei"/>
               </a:rPr>
-              <a:t>中间这一段无人值守。A 建立工作基线，全量评测，启动失败就按日志证据提修复，最多六次；B 是可选的 profiling，只用来定位、不参与收益计算；C 是候选迭代，每个候选打补丁、连过三道门、记录收益，最多六轮——右边这个回环就是它；D 最终复验，重测基线，再对每个候选做全量复验，相对两个基线都提升才计入。</a:t>
+              <a:t>中间整段无人值守，四个阶段中只有 C 是循环的：每个候选依次通过三道门禁，全部通过后才记录收益，最多六轮。另有两点需要说明：B 阶段的性能剖析只用于定位瓶颈，其数据不计入收益；D 阶段会重新测量一次基线，候选相对前后两个基线均有提升才予以计入。</a:t>
             </a:r>
           </a:p>
           <a:p>
@@ -624,7 +624,7 @@
                 <a:ea typeface="Microsoft YaHei"/>
                 <a:cs typeface="Microsoft YaHei"/>
               </a:rPr>
-              <a:t>结尾交回给人：读 report 和 best，验证通过就 export 出一份独立的 launch.sh，引用的是 run 里的隔离副本，不写回共享环境；失败或者没有收益，人工接手。出了问题能回到任意一轮。</a:t>
+              <a:t>结束之后交回人工：验收通过则导出 launch.sh，其中引用的是本次运行内的隔离副本，不写回共享环境，所以这份结果可以被独立复现；失败或无有效收益则转人工处理。</a:t>
             </a:r>
           </a:p>
           <a:p>
@@ -642,7 +642,7 @@
                 <a:ea typeface="Microsoft YaHei"/>
                 <a:cs typeface="Microsoft YaHei"/>
               </a:rPr>
-              <a:t>最下面这条回环是外循环，也是这套东西真正的价值所在：验证过的结论沉淀成诊断规则和候选，下一个模型直接复用。所以人工判断是逐个模型往下降的——这正好回答前面那页的命题。</a:t>
+              <a:t>最下方这条回环是外循环，也是这套机制的长期价值：经复验的结论沉淀为诊断规则与候选库，供下一个模型直接复用，人工判断的比重逐轮下降——这正好回应前一页提出的问题。</a:t>
             </a:r>
           </a:p>
           <a:p>
@@ -678,7 +678,7 @@
                 <a:ea typeface="Microsoft YaHei"/>
                 <a:cs typeface="Microsoft YaHei"/>
               </a:rPr>
-              <a:t>预算 36000 秒，最终复验预留 600 秒。这个预留我认为偏小：最多 6 轮完整复验摊下来一轮一百秒，而一轮要起服务、过三道门、跑全量评测。建议按候选数量和实测单轮耗时自适应。</a:t>
+              <a:t>总预算 36000 秒，最终复验预留 600 秒。这个预留偏小：最多 6 轮完整复验，平均每轮只有一百秒，而一轮需要启动服务、通过三道门禁并跑完全量评测。建议按候选数量与实测单轮耗时自适应调整。</a:t>
             </a:r>
           </a:p>
           <a:p>
@@ -696,7 +696,7 @@
                 <a:ea typeface="Microsoft YaHei"/>
                 <a:cs typeface="Microsoft YaHei"/>
               </a:rPr>
-              <a:t>恢复不重置 deadline，所以临近尾声被中断再恢复，阶段 D 可能拿不到足额预留，必要时应该显式延长并记进 state。</a:t>
+              <a:t>resume 不重置 deadline，因此临近结束时被中断再恢复，D 阶段可能无法获得足额预留，必要时应显式延长并记入 state。</a:t>
             </a:r>
           </a:p>
           <a:p>
@@ -714,7 +714,7 @@
                 <a:ea typeface="Microsoft YaHei"/>
                 <a:cs typeface="Microsoft YaHei"/>
               </a:rPr>
-              <a:t>已验收的候选不会成为新基线，候选永远从基线分叉，所以多个独立收益不会叠加——一次 run 交付的是最好的那一个，不是它们的组合。</a:t>
+              <a:t>已验收的候选不会成为新基线，后续候选始终从基线分叉，因此多个独立收益不会叠加——一次运行交付的是其中最好的一个，而不是它们的组合。</a:t>
             </a:r>
           </a:p>
         </p:txBody>
@@ -797,7 +797,7 @@
                 <a:ea typeface="Microsoft YaHei"/>
                 <a:cs typeface="Microsoft YaHei"/>
               </a:rPr>
-              <a:t>【Agent 门禁 · 约 105 秒（1:45）】</a:t>
+              <a:t>【Agent 门禁 · 约 115 秒（1:55）】</a:t>
             </a:r>
           </a:p>
           <a:p>
@@ -815,7 +815,7 @@
                 <a:ea typeface="Microsoft YaHei"/>
                 <a:cs typeface="Microsoft YaHei"/>
               </a:rPr>
-              <a:t>这一页是上一页 C 阶段的放大：里面的每一个候选，都要走完左边这条流水线。</a:t>
+              <a:t>本页是上一页 C 阶段的放大：其中每一个候选，都要完整走过左侧这条流水线。</a:t>
             </a:r>
           </a:p>
           <a:p>
@@ -833,7 +833,7 @@
                 <a:ea typeface="Microsoft YaHei"/>
                 <a:cs typeface="Microsoft YaHei"/>
               </a:rPr>
-              <a:t>先准备：在隔离副本上打补丁、生成完整 diff，需要的话跑算子生成和构建，再给编译后的产物记一次身份。服务起来时还要核对端口、PCI 和 model_path，防止串台。</a:t>
+              <a:t>准备阶段在隔离副本上应用补丁，必要时执行算子生成与构建，再为编译产物记录一次身份。服务启动时核对端口、PCI 与 model_path，确保被测对象确实是该候选。</a:t>
             </a:r>
           </a:p>
           <a:p>
@@ -851,7 +851,7 @@
                 <a:ea typeface="Microsoft YaHei"/>
                 <a:cs typeface="Microsoft YaHei"/>
               </a:rPr>
-              <a:t>然后连过三道门，顺序是从便宜到贵。数值门：三段固定文本做 teacher-forcing，贪心输出的 token 必须完全一致，logprob 最大绝对差不超过 0.03。质量门：同一批 MMStar 题目，正确率零下降，解析率也不许降。性能门：四个指标各重复三次取中位，任一指标回归不超过 5%，有效收益要同时大于 3% 和实测噪声极差。任一道不过立即返回，不浪费后面的设备时间。</a:t>
+              <a:t>三道门禁按成本由低到高排列，这个顺序是刻意安排的：成本最低的数值门先拦下大部分错误实现，不通过即终止，不再占用后续设备时间。数值门比较的是贪心输出的 token 是否完全一致，质量门比较的是同一批 MMStar 题目的正确率，性能门要求四项指标各重复三次取中位，收益须同时大于 3% 与实测噪声极差——换言之，低于噪声水平的提升不计为收益。</a:t>
             </a:r>
           </a:p>
           <a:p>
@@ -869,7 +869,7 @@
                 <a:ea typeface="Microsoft YaHei"/>
                 <a:cs typeface="Microsoft YaHei"/>
               </a:rPr>
-              <a:t>下面两条是防作弊：prompt 的 token 数必须等于冻结值，出现前缀缓存命中直接拒；精度、缓存这些口径一律不许动——不能靠偷工减料来变快。</a:t>
+              <a:t>下方两条是防作弊约束。这类系统最常见的失效方式，是候选通过减少实际工作量换取速度：命中前缀缓存、缩短上下文、降低精度。因此 prompt 的 token 数必须等于冻结值，出现缓存命中即判定不通过。</a:t>
             </a:r>
           </a:p>
           <a:p>
@@ -887,7 +887,7 @@
                 <a:ea typeface="Microsoft YaHei"/>
                 <a:cs typeface="Microsoft YaHei"/>
               </a:rPr>
-              <a:t>右边就是这条流水线判出来的结果。要强调的是口径：图里的收益都是最终复验通过的，筛选阶段看起来有收益、复验没过的，一个都不算。</a:t>
+              <a:t>右侧是这条流水线判定出的结果。需要强调口径：图中的收益全部来自最终复验通过的候选，筛选阶段看似有收益、复验未通过的，一律不计入。</a:t>
             </a:r>
           </a:p>
           <a:p>
@@ -923,7 +923,7 @@
                 <a:ea typeface="Microsoft YaHei"/>
                 <a:cs typeface="Microsoft YaHei"/>
               </a:rPr>
-              <a:t>正确率零容差在 24 题的筛选集上一道题就是 4.17 个百分点，而且和容许 0.03 logprob 漂移自相矛盾：漂移唯一的表现形式就是临界题翻转。建议改成同一批题目上的配对检验。</a:t>
+              <a:t>正确率零容差在 24 题的筛选集上，一道题即相当于 4.17 个百分点，并且与容许 0.03 的 logprob 漂移相互矛盾：漂移唯一的表现形式就是临界题翻转。建议改为同一批题目上的配对检验。</a:t>
             </a:r>
           </a:p>
           <a:p>
@@ -941,7 +941,7 @@
                 <a:ea typeface="Microsoft YaHei"/>
                 <a:cs typeface="Microsoft YaHei"/>
               </a:rPr>
-              <a:t>3 次重复的极差只能算粗估，而且基线与候选是十小时窗口里的不同时间块，设备漂移会直接进对比。要让数字经得起追问，得在同一窗口里交错测 A/B/A。</a:t>
+              <a:t>3 次重复的极差只能作为粗略估计，且基线与候选分处十小时窗口中的不同时间段，设备漂移会直接进入对比。要让数字经得起追问，需要在同一窗口内交错测量 A/B/A。</a:t>
             </a:r>
           </a:p>
           <a:p>
@@ -959,7 +959,7 @@
                 <a:ea typeface="Microsoft YaHei"/>
                 <a:cs typeface="Microsoft YaHei"/>
               </a:rPr>
-              <a:t>数值门比的是候选与 M100 基线，不是参考实现，所以基线自身的数值错误发现不了。接入线已经有冻结的独立 CPU 参考，调优线应该在阶段 A 继承一次。</a:t>
+              <a:t>数值门比较的是候选与 M100 基线，而非参考实现，因此基线自身的数值错误无法发现。架构接入阶段已有冻结的独立 CPU 参考，性能调优阶段应在 A 阶段继承一次。</a:t>
             </a:r>
           </a:p>
         </p:txBody>
@@ -4007,7 +4007,7 @@
                 <a:ea typeface="Microsoft YaHei"/>
                 <a:cs typeface="Microsoft YaHei"/>
               </a:rPr>
-              <a:t>AGENT 框架 · 人与 AGENT 的分工</a:t>
+              <a:t>AGENT 框架 · 人工与 AGENT 的职责划分</a:t>
             </a:r>
           </a:p>
         </p:txBody>
@@ -4054,7 +4054,7 @@
                 <a:ea typeface="Microsoft YaHei"/>
                 <a:cs typeface="Microsoft YaHei"/>
               </a:rPr>
-              <a:t>人定目标与口径，Agent 自动闭环，结论回到人手里</a:t>
+              <a:t>人工设定目标与口径，Agent 全程自动执行，结论交回人工判定</a:t>
             </a:r>
           </a:p>
         </p:txBody>
@@ -4101,7 +4101,7 @@
                 <a:ea typeface="Microsoft YaHei"/>
                 <a:cs typeface="Microsoft YaHei"/>
               </a:rPr>
-              <a:t>人只在两头：开头定契约与口径，结尾读结论定交付；中间的候选迭代与三道门全自动</a:t>
+              <a:t>人工只出现在首尾两端：开始前冻结契约，结束后判定交付；中间的候选迭代与门禁裁决全部自动执行</a:t>
             </a:r>
           </a:p>
         </p:txBody>
@@ -4177,7 +4177,7 @@
                 <a:ea typeface="Microsoft YaHei"/>
                 <a:cs typeface="Microsoft YaHei"/>
               </a:rPr>
-              <a:t>接入线</a:t>
+              <a:t>架构接入</a:t>
             </a:r>
             <a:r>
               <a:rPr sz="950" b="0">
@@ -4199,7 +4199,7 @@
                 <a:ea typeface="Microsoft YaHei"/>
                 <a:cs typeface="Microsoft YaHei"/>
               </a:rPr>
-              <a:t>　新架构接入与分层验收</a:t>
+              <a:t>　分八层逐层验收</a:t>
             </a:r>
           </a:p>
         </p:txBody>
@@ -4275,7 +4275,7 @@
                 <a:ea typeface="Microsoft YaHei"/>
                 <a:cs typeface="Microsoft YaHei"/>
               </a:rPr>
-              <a:t>调优线</a:t>
+              <a:t>性能调优</a:t>
             </a:r>
             <a:r>
               <a:rPr sz="950" b="0">
@@ -4297,7 +4297,7 @@
                 <a:ea typeface="Microsoft YaHei"/>
                 <a:cs typeface="Microsoft YaHei"/>
               </a:rPr>
-              <a:t>　实测性能调优</a:t>
+              <a:t>　实测环境下迭代优化</a:t>
             </a:r>
           </a:p>
         </p:txBody>
@@ -4395,7 +4395,7 @@
                 <a:ea typeface="Microsoft YaHei"/>
                 <a:cs typeface="Microsoft YaHei"/>
               </a:rPr>
-              <a:t>优化线</a:t>
+              <a:t>持续优化</a:t>
             </a:r>
             <a:r>
               <a:rPr sz="950" b="0">
@@ -4417,7 +4417,7 @@
                 <a:ea typeface="Microsoft YaHei"/>
                 <a:cs typeface="Microsoft YaHei"/>
               </a:rPr>
-              <a:t>　trace 驱动的持续迭代</a:t>
+              <a:t>　基于 trace 持续迭代</a:t>
             </a:r>
           </a:p>
         </p:txBody>
@@ -4544,7 +4544,7 @@
                 <a:ea typeface="Microsoft YaHei"/>
                 <a:cs typeface="Microsoft YaHei"/>
               </a:rPr>
-              <a:t>人</a:t>
+              <a:t>人工</a:t>
             </a:r>
             <a:r>
               <a:rPr sz="1150" b="0">
@@ -4555,7 +4555,7 @@
                 <a:ea typeface="Microsoft YaHei"/>
                 <a:cs typeface="Microsoft YaHei"/>
               </a:rPr>
-              <a:t>　定目标与口径</a:t>
+              <a:t>　设定目标与口径</a:t>
             </a:r>
           </a:p>
         </p:txBody>
@@ -4631,7 +4631,7 @@
                 <a:ea typeface="Microsoft YaHei"/>
                 <a:cs typeface="Microsoft YaHei"/>
               </a:rPr>
-              <a:t>模型 / 负载 / 并发</a:t>
+              <a:t>目标模型、负载与并发</a:t>
             </a:r>
           </a:p>
         </p:txBody>
@@ -4707,7 +4707,7 @@
                 <a:ea typeface="Microsoft YaHei"/>
                 <a:cs typeface="Microsoft YaHei"/>
               </a:rPr>
-              <a:t>四个阈值与预算</a:t>
+              <a:t>四项阈值与时间预算</a:t>
             </a:r>
           </a:p>
         </p:txBody>
@@ -4906,7 +4906,7 @@
                 <a:ea typeface="Microsoft YaHei"/>
                 <a:cs typeface="Microsoft YaHei"/>
               </a:rPr>
-              <a:t>契约冻结后被改 → 拒绝继续</a:t>
+              <a:t>契约一经冻结，修改即终止</a:t>
             </a:r>
           </a:p>
         </p:txBody>
@@ -4953,7 +4953,7 @@
                 <a:ea typeface="Microsoft YaHei"/>
                 <a:cs typeface="Microsoft YaHei"/>
               </a:rPr>
-              <a:t>交给 Agent</a:t>
+              <a:t>移交 Agent</a:t>
             </a:r>
           </a:p>
         </p:txBody>
@@ -5042,7 +5042,7 @@
                 <a:ea typeface="Microsoft YaHei"/>
                 <a:cs typeface="Microsoft YaHei"/>
               </a:rPr>
-              <a:t>　自动闭环，无人值守</a:t>
+              <a:t>　全程自动执行，无人值守</a:t>
             </a:r>
             <a:r>
               <a:rPr sz="1000" b="0">
@@ -5053,7 +5053,7 @@
                 <a:ea typeface="Microsoft YaHei"/>
                 <a:cs typeface="Microsoft YaHei"/>
               </a:rPr>
-              <a:t>　执行前先校验备份 / 题集 / 图片 sha256</a:t>
+              <a:t>　启动前校验备份、题集与图片的 sha256</a:t>
             </a:r>
           </a:p>
         </p:txBody>
@@ -5148,7 +5148,7 @@
         <p:spPr>
           <a:xfrm>
             <a:off x="3694176" y="2816352"/>
-            <a:ext cx="1280160" cy="493776"/>
+            <a:ext cx="1097280" cy="493776"/>
           </a:xfrm>
           <a:prstGeom prst="rect">
             <a:avLst/>
@@ -5194,8 +5194,8 @@
         </p:nvSpPr>
         <p:spPr>
           <a:xfrm>
-            <a:off x="4892040" y="2816352"/>
-            <a:ext cx="3200400" cy="493776"/>
+            <a:off x="4800600" y="2816352"/>
+            <a:ext cx="3246120" cy="493776"/>
           </a:xfrm>
           <a:prstGeom prst="rect">
             <a:avLst/>
@@ -5228,7 +5228,7 @@
                 <a:ea typeface="Microsoft YaHei"/>
                 <a:cs typeface="Microsoft YaHei"/>
               </a:rPr>
-              <a:t>全量评测；启动失败按证据提修复，最多 6 次</a:t>
+              <a:t>全量评测确立对照基准；启动失败最多修复 6 次</a:t>
             </a:r>
           </a:p>
         </p:txBody>
@@ -5323,7 +5323,7 @@
         <p:spPr>
           <a:xfrm>
             <a:off x="3694176" y="3346704"/>
-            <a:ext cx="1280160" cy="493776"/>
+            <a:ext cx="1097280" cy="493776"/>
           </a:xfrm>
           <a:prstGeom prst="rect">
             <a:avLst/>
@@ -5356,7 +5356,7 @@
                 <a:ea typeface="Microsoft YaHei"/>
                 <a:cs typeface="Microsoft YaHei"/>
               </a:rPr>
-              <a:t>Profiling</a:t>
+              <a:t>性能剖析</a:t>
             </a:r>
           </a:p>
         </p:txBody>
@@ -5369,8 +5369,8 @@
         </p:nvSpPr>
         <p:spPr>
           <a:xfrm>
-            <a:off x="4892040" y="3346704"/>
-            <a:ext cx="3200400" cy="493776"/>
+            <a:off x="4800600" y="3346704"/>
+            <a:ext cx="3246120" cy="493776"/>
           </a:xfrm>
           <a:prstGeom prst="rect">
             <a:avLst/>
@@ -5403,7 +5403,7 @@
                 <a:ea typeface="Microsoft YaHei"/>
                 <a:cs typeface="Microsoft YaHei"/>
               </a:rPr>
-              <a:t>独立进程采 trace，只用于定位，不参与收益计算</a:t>
+              <a:t>独立进程采集 trace，仅用于定位，不计入收益</a:t>
             </a:r>
           </a:p>
         </p:txBody>
@@ -5498,7 +5498,7 @@
         <p:spPr>
           <a:xfrm>
             <a:off x="3694176" y="3877056"/>
-            <a:ext cx="1280160" cy="493776"/>
+            <a:ext cx="1097280" cy="493776"/>
           </a:xfrm>
           <a:prstGeom prst="rect">
             <a:avLst/>
@@ -5544,8 +5544,8 @@
         </p:nvSpPr>
         <p:spPr>
           <a:xfrm>
-            <a:off x="4892040" y="3877056"/>
-            <a:ext cx="3200400" cy="493776"/>
+            <a:off x="4800600" y="3877056"/>
+            <a:ext cx="3246120" cy="493776"/>
           </a:xfrm>
           <a:prstGeom prst="rect">
             <a:avLst/>
@@ -5578,7 +5578,7 @@
                 <a:ea typeface="Microsoft YaHei"/>
                 <a:cs typeface="Microsoft YaHei"/>
               </a:rPr>
-              <a:t>每个候选打补丁 → 过三道门 → 记收益，最多 6 轮</a:t>
+              <a:t>每个候选依次通过三道门禁并记录收益，最多 6 轮</a:t>
             </a:r>
           </a:p>
         </p:txBody>
@@ -5723,7 +5723,7 @@
         <p:spPr>
           <a:xfrm>
             <a:off x="3694176" y="4407408"/>
-            <a:ext cx="1280160" cy="493776"/>
+            <a:ext cx="1097280" cy="493776"/>
           </a:xfrm>
           <a:prstGeom prst="rect">
             <a:avLst/>
@@ -5769,8 +5769,8 @@
         </p:nvSpPr>
         <p:spPr>
           <a:xfrm>
-            <a:off x="4892040" y="4407408"/>
-            <a:ext cx="3200400" cy="493776"/>
+            <a:off x="4800600" y="4407408"/>
+            <a:ext cx="3246120" cy="493776"/>
           </a:xfrm>
           <a:prstGeom prst="rect">
             <a:avLst/>
@@ -5803,7 +5803,7 @@
                 <a:ea typeface="Microsoft YaHei"/>
                 <a:cs typeface="Microsoft YaHei"/>
               </a:rPr>
-              <a:t>重测基线，每个候选全量复验；两基线都提升才计入</a:t>
+              <a:t>重测基线后全量复验，相对两个基线均提升方可计入</a:t>
             </a:r>
           </a:p>
         </p:txBody>
@@ -5816,8 +5816,8 @@
         </p:nvSpPr>
         <p:spPr>
           <a:xfrm>
-            <a:off x="4892040" y="4956048"/>
-            <a:ext cx="3657600" cy="237744"/>
+            <a:off x="4800600" y="4956048"/>
+            <a:ext cx="3703320" cy="237744"/>
           </a:xfrm>
           <a:prstGeom prst="rect">
             <a:avLst/>
@@ -5850,7 +5850,7 @@
                 <a:ea typeface="Microsoft YaHei"/>
                 <a:cs typeface="Microsoft YaHei"/>
               </a:rPr>
-              <a:t>一个候选怎么被判 → 下一页</a:t>
+              <a:t>单个候选的判定流程见下页</a:t>
             </a:r>
           </a:p>
         </p:txBody>
@@ -5955,7 +5955,7 @@
                 <a:ea typeface="Microsoft YaHei"/>
                 <a:cs typeface="Microsoft YaHei"/>
               </a:rPr>
-              <a:t>人</a:t>
+              <a:t>人工</a:t>
             </a:r>
             <a:r>
               <a:rPr sz="1150" b="0">
@@ -5966,7 +5966,7 @@
                 <a:ea typeface="Microsoft YaHei"/>
                 <a:cs typeface="Microsoft YaHei"/>
               </a:rPr>
-              <a:t>　读结论、定交付</a:t>
+              <a:t>　判定结论与交付</a:t>
             </a:r>
           </a:p>
         </p:txBody>
@@ -6042,7 +6042,7 @@
                 <a:ea typeface="Microsoft YaHei"/>
                 <a:cs typeface="Microsoft YaHei"/>
               </a:rPr>
-              <a:t>读 report.md 与 best.json</a:t>
+              <a:t>审阅 report.md 与 best.json</a:t>
             </a:r>
           </a:p>
         </p:txBody>
@@ -6118,7 +6118,7 @@
                 <a:ea typeface="Microsoft YaHei"/>
                 <a:cs typeface="Microsoft YaHei"/>
               </a:rPr>
-              <a:t>验证通过 → export launch.sh</a:t>
+              <a:t>验收通过：导出 launch.sh</a:t>
             </a:r>
           </a:p>
         </p:txBody>
@@ -6194,7 +6194,7 @@
                 <a:ea typeface="Microsoft YaHei"/>
                 <a:cs typeface="Microsoft YaHei"/>
               </a:rPr>
-              <a:t>失败或无收益 → 人工接手</a:t>
+              <a:t>失败或无收益：转人工处理</a:t>
             </a:r>
           </a:p>
         </p:txBody>
@@ -6270,7 +6270,7 @@
                 <a:ea typeface="Microsoft YaHei"/>
                 <a:cs typeface="Microsoft YaHei"/>
               </a:rPr>
-              <a:t>每一轮都可回放追溯</a:t>
+              <a:t>每一轮均可回放追溯</a:t>
             </a:r>
           </a:p>
         </p:txBody>
@@ -6317,7 +6317,7 @@
                 <a:ea typeface="Microsoft YaHei"/>
                 <a:cs typeface="Microsoft YaHei"/>
               </a:rPr>
-              <a:t>导出的 launch.sh 引用 run 内副本</a:t>
+              <a:t>导出脚本引用 run 内的隔离副本</a:t>
             </a:r>
           </a:p>
         </p:txBody>
@@ -6364,7 +6364,7 @@
                 <a:ea typeface="Microsoft YaHei"/>
                 <a:cs typeface="Microsoft YaHei"/>
               </a:rPr>
-              <a:t>交回给人</a:t>
+              <a:t>交回人工</a:t>
             </a:r>
           </a:p>
         </p:txBody>
@@ -6461,7 +6461,7 @@
                 <a:ea typeface="Microsoft YaHei"/>
                 <a:cs typeface="Microsoft YaHei"/>
               </a:rPr>
-              <a:t>验证过的结论沉淀成诊断规则与候选 —— 下一个模型直接复用，人工判断逐次减少</a:t>
+              <a:t>经复验的结论沉淀为诊断规则与候选库，供下一个模型直接复用，人工判断逐轮减少</a:t>
             </a:r>
           </a:p>
         </p:txBody>
@@ -6508,7 +6508,7 @@
                 <a:ea typeface="Microsoft YaHei"/>
                 <a:cs typeface="Microsoft YaHei"/>
               </a:rPr>
-              <a:t>onboard --optimize 验收通过后自动交接到优化；预算 36000s，最终复验预留 600s</a:t>
+              <a:t>架构接入验收通过后，onboard --optimize 自动交接至优化阶段；总预算 36000 秒，最终复验预留 600 秒</a:t>
             </a:r>
           </a:p>
         </p:txBody>
@@ -6620,7 +6620,7 @@
                 <a:ea typeface="Microsoft YaHei"/>
                 <a:cs typeface="Microsoft YaHei"/>
               </a:rPr>
-              <a:t>AGENT 门禁 · 一个候选怎么被判</a:t>
+              <a:t>AGENT 门禁 · 单个候选的判定流程</a:t>
             </a:r>
           </a:p>
         </p:txBody>
@@ -6667,7 +6667,7 @@
                 <a:ea typeface="Microsoft YaHei"/>
                 <a:cs typeface="Microsoft YaHei"/>
               </a:rPr>
-              <a:t>三道门由便宜到贵，任一道不过立即返回</a:t>
+              <a:t>三道门禁按成本由低到高排列，任一道不通过即终止该候选</a:t>
             </a:r>
           </a:p>
         </p:txBody>
@@ -6714,7 +6714,7 @@
                 <a:ea typeface="Microsoft YaHei"/>
                 <a:cs typeface="Microsoft YaHei"/>
               </a:rPr>
-              <a:t>上一页 C 阶段里的每个候选都要走完这条流水线；判据是固定阈值，不由模型解释</a:t>
+              <a:t>上页 C 阶段的每个候选都要走完这条流水线；判据为契约中的固定阈值，不经模型解释</a:t>
             </a:r>
           </a:p>
         </p:txBody>
@@ -6772,7 +6772,7 @@
                 <a:ea typeface="Microsoft YaHei"/>
                 <a:cs typeface="Microsoft YaHei"/>
               </a:rPr>
-              <a:t>隔离副本 + 打补丁　→　算子生成 / 构建　→　产物身份 manifest</a:t>
+              <a:t>在隔离副本上应用补丁　→　算子生成与构建　→　记录产物身份 manifest</a:t>
             </a:r>
           </a:p>
         </p:txBody>
@@ -6859,7 +6859,7 @@
                 <a:ea typeface="Microsoft YaHei"/>
                 <a:cs typeface="Microsoft YaHei"/>
               </a:rPr>
-              <a:t>　启动即核对身份：端口先 bind · PCI 二次核对 · model_path 比对</a:t>
+              <a:t>　启动时核对身份：先 bind 端口 · 二次核对 PCI · 比对 model_path</a:t>
             </a:r>
           </a:p>
         </p:txBody>
@@ -7031,7 +7031,7 @@
                 <a:ea typeface="Microsoft YaHei"/>
                 <a:cs typeface="Microsoft YaHei"/>
               </a:rPr>
-              <a:t>贪心 token 完全一致</a:t>
+              <a:t>贪心输出 token 完全一致</a:t>
             </a:r>
           </a:p>
         </p:txBody>
@@ -7250,7 +7250,7 @@
                 <a:ea typeface="Microsoft YaHei"/>
                 <a:cs typeface="Microsoft YaHei"/>
               </a:rPr>
-              <a:t>正确率零下降</a:t>
+              <a:t>正确率不得下降</a:t>
             </a:r>
           </a:p>
         </p:txBody>
@@ -7297,7 +7297,7 @@
                 <a:ea typeface="Microsoft YaHei"/>
                 <a:cs typeface="Microsoft YaHei"/>
               </a:rPr>
-              <a:t>解析率不得降，同一批题</a:t>
+              <a:t>同一批题目，解析率不得下降</a:t>
             </a:r>
           </a:p>
         </p:txBody>
@@ -7516,7 +7516,7 @@
                 <a:ea typeface="Microsoft YaHei"/>
                 <a:cs typeface="Microsoft YaHei"/>
               </a:rPr>
-              <a:t>3 次取中位，还要大于噪声极差</a:t>
+              <a:t>重复 3 次取中位，并须大于噪声极差</a:t>
             </a:r>
           </a:p>
         </p:txBody>
@@ -7574,7 +7574,7 @@
                 <a:ea typeface="Microsoft YaHei"/>
                 <a:cs typeface="Microsoft YaHei"/>
               </a:rPr>
-              <a:t>　候选不能靠减少工作量换“变快”</a:t>
+              <a:t>　候选不得通过减少实际工作量换取速度</a:t>
             </a:r>
           </a:p>
         </p:txBody>
@@ -7650,7 +7650,7 @@
                 <a:ea typeface="Microsoft YaHei"/>
                 <a:cs typeface="Microsoft YaHei"/>
               </a:rPr>
-              <a:t>prompt_tokens 必须等于冻结的 input_tokens；前缀缓存命中（cached_tokens &gt; 0）直接拒</a:t>
+              <a:t>prompt_tokens 必须等于冻结值；出现前缀缓存命中（cached_tokens &gt; 0）即判定不通过</a:t>
             </a:r>
           </a:p>
         </p:txBody>
@@ -7726,7 +7726,7 @@
                 <a:ea typeface="Microsoft YaHei"/>
                 <a:cs typeface="Microsoft YaHei"/>
               </a:rPr>
-              <a:t>精度 / dtype / 缓存 / 上下文长度一律冻结，候选 env 限白名单且不得开 profiler</a:t>
+              <a:t>精度、dtype、缓存、上下文长度一律冻结；候选环境变量限白名单，不得开启 profiler</a:t>
             </a:r>
           </a:p>
         </p:txBody>
@@ -7805,7 +7805,7 @@
                 <a:ea typeface="Microsoft YaHei"/>
                 <a:cs typeface="Microsoft YaHei"/>
               </a:rPr>
-              <a:t>建议：优化曲线 / 收敛曲线</a:t>
+              <a:t>建议使用优化收益曲线</a:t>
             </a:r>
           </a:p>
           <a:p>
@@ -7829,7 +7829,7 @@
                 <a:ea typeface="Microsoft YaHei"/>
                 <a:cs typeface="Microsoft YaHei"/>
               </a:rPr>
-              <a:t>横轴每一轮候选，纵轴收益；复验通过的单独标出</a:t>
+              <a:t>横轴为候选轮次，纵轴为收益；复验通过者单独标注</a:t>
             </a:r>
           </a:p>
           <a:p>
@@ -8016,7 +8016,7 @@
                 <a:ea typeface="Microsoft YaHei"/>
                 <a:cs typeface="Microsoft YaHei"/>
               </a:rPr>
-              <a:t>数值门与质量门在 evaluation.py，性能门在 benchmark.py；阈值全部来自冻结契约，候选无权修改</a:t>
+              <a:t>数值门与质量门实现于 evaluation.py，性能门实现于 benchmark.py；阈值均来自冻结契约，候选无权修改</a:t>
             </a:r>
           </a:p>
         </p:txBody>

</xml_diff>

<commit_message>
Name the three gates by what they require
数值门 / 质量门 / 性能门 name the dimension, not the condition, so each
one needed a sentence of explanation before it meant anything. 输出未变
/ 质量未降 / 确实更快 state the passing condition directly and parallel
the operator-level chain on the overview page, where 更快 now appears on
both sides -- which is exactly the point the closing band makes.

The code-level names stay in the footer, next to the files that
implement them.
</commit_message>
<xml_diff>
--- a/slides/m100_model_agent.pptx
+++ b/slides/m100_model_agent.pptx
@@ -797,7 +797,7 @@
                 <a:ea typeface="Microsoft YaHei"/>
                 <a:cs typeface="Microsoft YaHei"/>
               </a:rPr>
-              <a:t>【Agent 门禁 · 约 115 秒（1:55）】</a:t>
+              <a:t>【Agent 门禁 · 约 125 秒（2:05）】</a:t>
             </a:r>
           </a:p>
           <a:p>
@@ -851,7 +851,7 @@
                 <a:ea typeface="Microsoft YaHei"/>
                 <a:cs typeface="Microsoft YaHei"/>
               </a:rPr>
-              <a:t>三道门禁按成本由低到高排列，这个顺序是刻意安排的：成本最低的数值门先拦下大部分错误实现，不通过即终止，不再占用后续设备时间。数值门比较的是贪心输出的 token 是否完全一致，质量门比较的是同一批 MMStar 题目的正确率，性能门要求四项指标各重复三次取中位，收益须同时大于 3% 与实测噪声极差——换言之，低于噪声水平的提升不计为收益。</a:t>
+              <a:t>三道门禁按成本由低到高排列，这个顺序是刻意安排的：成本最低的第一道先拦下大部分错误实现，不通过即终止，不再占用后续设备时间。第一道看输出有没有变，判据是贪心输出的 token 完全一致；第二道看质量有没有降，判据是同一批 MMStar 题目的正确率与解析率；第三道看是不是确实更快，四项指标各重复三次取中位，收益须同时大于 3% 与实测噪声极差——换言之，低于噪声水平的提升不计为收益。代码里它们分别叫数值门、质量门、性能门。</a:t>
             </a:r>
           </a:p>
           <a:p>
@@ -959,7 +959,7 @@
                 <a:ea typeface="Microsoft YaHei"/>
                 <a:cs typeface="Microsoft YaHei"/>
               </a:rPr>
-              <a:t>数值门比较的是候选与 M100 基线，而非参考实现，因此基线自身的数值错误无法发现。架构接入阶段已有冻结的独立 CPU 参考，性能调优阶段应在 A 阶段继承一次。</a:t>
+              <a:t>第一道比较的是候选与 M100 基线，而非参考实现，因此基线自身的数值错误无法发现。架构接入阶段已有冻结的独立 CPU 参考，性能调优阶段应在 A 阶段继承一次。</a:t>
             </a:r>
           </a:p>
         </p:txBody>
@@ -6984,7 +6984,7 @@
                 <a:ea typeface="Microsoft YaHei"/>
                 <a:cs typeface="Microsoft YaHei"/>
               </a:rPr>
-              <a:t>数值门</a:t>
+              <a:t>输出未变</a:t>
             </a:r>
           </a:p>
         </p:txBody>
@@ -7031,7 +7031,7 @@
                 <a:ea typeface="Microsoft YaHei"/>
                 <a:cs typeface="Microsoft YaHei"/>
               </a:rPr>
-              <a:t>贪心输出 token 完全一致</a:t>
+              <a:t>贪心 token 完全一致</a:t>
             </a:r>
           </a:p>
         </p:txBody>
@@ -7203,7 +7203,7 @@
                 <a:ea typeface="Microsoft YaHei"/>
                 <a:cs typeface="Microsoft YaHei"/>
               </a:rPr>
-              <a:t>质量门</a:t>
+              <a:t>质量未降</a:t>
             </a:r>
           </a:p>
         </p:txBody>
@@ -7250,7 +7250,7 @@
                 <a:ea typeface="Microsoft YaHei"/>
                 <a:cs typeface="Microsoft YaHei"/>
               </a:rPr>
-              <a:t>正确率不得下降</a:t>
+              <a:t>正确率、解析率均不降</a:t>
             </a:r>
           </a:p>
         </p:txBody>
@@ -7297,7 +7297,7 @@
                 <a:ea typeface="Microsoft YaHei"/>
                 <a:cs typeface="Microsoft YaHei"/>
               </a:rPr>
-              <a:t>同一批题目，解析率不得下降</a:t>
+              <a:t>同一批题目，筛选阶段取 24 题</a:t>
             </a:r>
           </a:p>
         </p:txBody>
@@ -7422,7 +7422,7 @@
                 <a:ea typeface="Microsoft YaHei"/>
                 <a:cs typeface="Microsoft YaHei"/>
               </a:rPr>
-              <a:t>性能门</a:t>
+              <a:t>确实更快</a:t>
             </a:r>
           </a:p>
         </p:txBody>

</xml_diff>